<commit_message>
Center WMT2020 on news translation data and its original evaluation
</commit_message>
<xml_diff>
--- a/slides/datasets-in-10-minutes-wmt2020-enzh.pptx
+++ b/slides/datasets-in-10-minutes-wmt2020-enzh.pptx
@@ -29,7 +29,6 @@
     <p:sldId id="277" r:id="rId27"/>
     <p:sldId id="278" r:id="rId28"/>
     <p:sldId id="279" r:id="rId29"/>
-    <p:sldId id="280" r:id="rId30"/>
     <p:sldId id="283" r:id="rId33"/>
     <p:sldId id="284" r:id="rId34"/>
     <p:sldId id="285" r:id="rId35"/>
@@ -54,7 +53,6 @@
     <p:sldId id="310" r:id="rId60"/>
     <p:sldId id="312" r:id="rId62"/>
     <p:sldId id="313" r:id="rId63"/>
-    <p:sldId id="314" r:id="rId64"/>
   </p:sldIdLst>
   <p:sldSz cx="9144000" cy="5143500" type="screen16x9"/>
   <p:notesSz cx="6858000" cy="9144000"/>
@@ -14350,7 +14348,7 @@
                 <a:ea typeface="Noto Sans CJK JP"/>
                 <a:cs typeface="Noto Sans"/>
               </a:rPr>
-              <a:t>CLEVAでも、ニュース翻訳を評価する</a:t>
+              <a:t>公開データの入手と利用条件</a:t>
             </a:r>
           </a:p>
         </p:txBody>
@@ -14398,7 +14396,7 @@
                 <a:ea typeface="Noto Sans CJK JP"/>
                 <a:cs typeface="Noto Sans"/>
               </a:rPr>
-              <a:t>4. CLEVAでの採用と利用条件</a:t>
+              <a:t>4. 入手と利用条件</a:t>
             </a:r>
           </a:p>
         </p:txBody>
@@ -14411,7 +14409,7 @@
 </p:sld>
 </file>
 
-<file path=ppt/slides/slide25.xml><?xml version="1.0" encoding="utf-8"?>
+<file path=ppt/slides/slide26.xml><?xml version="1.0" encoding="utf-8"?>
 <p:sld xmlns:a="http://schemas.openxmlformats.org/drawingml/2006/main" xmlns:p="http://schemas.openxmlformats.org/presentationml/2006/main" xmlns:r="http://schemas.openxmlformats.org/officeDocument/2006/relationships">
   <p:cSld>
     <p:spTree>
@@ -14464,7 +14462,7 @@
                 <a:ea typeface="Noto Sans CJK JP"/>
                 <a:cs typeface="Noto Sans"/>
               </a:rPr>
-              <a:t>CLEVAは、過去のWMTデータで翻訳を評価する</a:t>
+              <a:t>研究目的で利用でき、引用と権利の条件がある</a:t>
             </a:r>
           </a:p>
         </p:txBody>
@@ -14493,61 +14491,61 @@
           <a:p>
             <a:pPr marL="457200" indent="-355600">
               <a:lnSpc>
-                <a:spcPts val="2261"/>
+                <a:spcPts val="2320"/>
               </a:lnSpc>
               <a:spcAft>
                 <a:spcPts val="700"/>
               </a:spcAft>
-              <a:buSzPct val="70000"/>
+              <a:buSzPct val="68205"/>
               <a:buFont typeface="Noto Sans CJK JP"/>
               <a:buChar char="●"/>
-              <a:defRPr sz="1900" b="0">
-                <a:solidFill>
-                  <a:srgbClr val="303437"/>
-                </a:solidFill>
-                <a:latin typeface="Noto Sans"/>
-              </a:defRPr>
-            </a:pPr>
-            <a:r>
-              <a:rPr sz="1900" b="0" lang="ja-JP" altLang="en-US">
-                <a:solidFill>
-                  <a:srgbClr val="303437"/>
-                </a:solidFill>
-                <a:latin typeface="Noto Sans"/>
-                <a:ea typeface="Noto Sans CJK JP"/>
-                <a:cs typeface="Noto Sans"/>
-              </a:rPr>
-              <a:t>CLEVAは、過去のWMT大会から英中翻訳データを集め、SacreBLEUで評価する。採用した年ごとの問題数は、公表されていない。</a:t>
+              <a:defRPr sz="1950" b="0">
+                <a:solidFill>
+                  <a:srgbClr val="303437"/>
+                </a:solidFill>
+                <a:latin typeface="Noto Sans"/>
+              </a:defRPr>
+            </a:pPr>
+            <a:r>
+              <a:rPr sz="1950" b="0" lang="ja-JP" altLang="en-US">
+                <a:solidFill>
+                  <a:srgbClr val="303437"/>
+                </a:solidFill>
+                <a:latin typeface="Noto Sans"/>
+                <a:ea typeface="Noto Sans CJK JP"/>
+                <a:cs typeface="Noto Sans"/>
+              </a:rPr>
+              <a:t>公式タスクページは、WMT20のデータを研究目的で自由に使えるとし、概要論文と各集合の追加引用条件を守るよう求める。</a:t>
             </a:r>
           </a:p>
           <a:p>
             <a:pPr marL="457200" indent="-355600">
               <a:lnSpc>
-                <a:spcPts val="2261"/>
+                <a:spcPts val="2320"/>
               </a:lnSpc>
               <a:spcAft>
                 <a:spcPts val="700"/>
               </a:spcAft>
-              <a:buSzPct val="70000"/>
+              <a:buSzPct val="68205"/>
               <a:buFont typeface="Noto Sans CJK JP"/>
               <a:buChar char="●"/>
-              <a:defRPr sz="1900" b="0">
-                <a:solidFill>
-                  <a:srgbClr val="303437"/>
-                </a:solidFill>
-                <a:latin typeface="Noto Sans"/>
-              </a:defRPr>
-            </a:pPr>
-            <a:r>
-              <a:rPr sz="1900" b="0" lang="ja-JP" altLang="en-US">
-                <a:solidFill>
-                  <a:srgbClr val="303437"/>
-                </a:solidFill>
-                <a:latin typeface="Noto Sans"/>
-                <a:ea typeface="Noto Sans CJK JP"/>
-                <a:cs typeface="Noto Sans"/>
-              </a:rPr>
-              <a:t>CLEVA論文の下院の見出しと、HELMの二つの翻訳例は、WMT2020通常配布の原文・参照訳と一致する。</a:t>
+              <a:defRPr sz="1950" b="0">
+                <a:solidFill>
+                  <a:srgbClr val="303437"/>
+                </a:solidFill>
+                <a:latin typeface="Noto Sans"/>
+              </a:defRPr>
+            </a:pPr>
+            <a:r>
+              <a:rPr sz="1950" b="0" lang="ja-JP" altLang="en-US">
+                <a:solidFill>
+                  <a:srgbClr val="303437"/>
+                </a:solidFill>
+                <a:latin typeface="Noto Sans"/>
+                <a:ea typeface="Noto Sans CJK JP"/>
+                <a:cs typeface="Noto Sans"/>
+              </a:rPr>
+              <a:t>それ以外の用途については、元データの権利者へ相談する条件になっている。</a:t>
             </a:r>
           </a:p>
         </p:txBody>
@@ -14595,7 +14593,7 @@
                 <a:ea typeface="Noto Sans CJK JP"/>
                 <a:cs typeface="Noto Sans"/>
               </a:rPr>
-              <a:t>4. CLEVAでの採用と利用条件</a:t>
+              <a:t>4. 入手と利用条件</a:t>
             </a:r>
           </a:p>
         </p:txBody>
@@ -14608,7 +14606,7 @@
         </p:nvSpPr>
         <p:spPr>
           <a:xfrm>
-            <a:off x="502920" y="4517136"/>
+            <a:off x="502920" y="4700016"/>
             <a:ext cx="8183879" cy="530352"/>
           </a:xfrm>
           <a:prstGeom prst="rect">
@@ -14649,7 +14647,7 @@
                 <a:ea typeface="Noto Sans CJK JP"/>
                 <a:cs typeface="Noto Sans"/>
               </a:rPr>
-              <a:t>[1] Li et al. (2023). CLEVA: Chinese Language Models EVAluation Platform. EMNLP System Demonstrations.</a:t>
+              <a:t>[1] WMT20. Shared Task: Machine Translation of News. Task, data and licensing.</a:t>
             </a:r>
             <a:r>
               <a:rPr sz="810" b="0" lang="ja-JP" altLang="en-US">
@@ -14672,14 +14670,237 @@
                 <a:cs typeface="Noto Sans"/>
                 <a:hlinkClick r:id="rId2"/>
               </a:rPr>
-              <a:t>https://aclanthology.org/2023.emnlp-demo.17/</a:t>
-            </a:r>
-          </a:p>
-          <a:p>
-            <a:pPr>
+              <a:t>https://www.statmt.org/wmt20/translation-task.html</a:t>
+            </a:r>
+          </a:p>
+        </p:txBody>
+      </p:sp>
+    </p:spTree>
+  </p:cSld>
+  <p:clrMapOvr>
+    <a:masterClrMapping/>
+  </p:clrMapOvr>
+</p:sld>
+</file>
+
+<file path=ppt/slides/slide27.xml><?xml version="1.0" encoding="utf-8"?>
+<p:sld xmlns:a="http://schemas.openxmlformats.org/drawingml/2006/main" xmlns:p="http://schemas.openxmlformats.org/presentationml/2006/main" xmlns:r="http://schemas.openxmlformats.org/officeDocument/2006/relationships">
+  <p:cSld>
+    <p:spTree>
+      <p:nvGrpSpPr>
+        <p:cNvPr id="1" name=""/>
+        <p:cNvGrpSpPr/>
+        <p:nvPr/>
+      </p:nvGrpSpPr>
+      <p:grpSpPr/>
+      <p:sp>
+        <p:nvSpPr>
+          <p:cNvPr id="2" name="Title 1"/>
+          <p:cNvSpPr>
+            <a:spLocks noGrp="1"/>
+          </p:cNvSpPr>
+          <p:nvPr>
+            <p:ph type="title"/>
+          </p:nvPr>
+        </p:nvSpPr>
+        <p:spPr>
+          <a:xfrm>
+            <a:off x="468172" y="650138"/>
+            <a:ext cx="8206740" cy="616305"/>
+          </a:xfrm>
+        </p:spPr>
+        <p:txBody>
+          <a:bodyPr wrap="square" lIns="0" rIns="0" tIns="0" bIns="0">
+            <a:noAutofit/>
+          </a:bodyPr>
+          <a:lstStyle/>
+          <a:p>
+            <a:pPr algn="l">
+              <a:lnSpc>
+                <a:spcPct val="110000"/>
+              </a:lnSpc>
+              <a:buNone/>
+              <a:defRPr sz="2800" b="0">
+                <a:solidFill>
+                  <a:srgbClr val="303437"/>
+                </a:solidFill>
+                <a:latin typeface="Noto Sans"/>
+              </a:defRPr>
+            </a:pPr>
+            <a:r>
+              <a:rPr sz="2800" b="1" lang="ja-JP" altLang="en-US">
+                <a:solidFill>
+                  <a:srgbClr val="303437"/>
+                </a:solidFill>
+                <a:latin typeface="Noto Sans"/>
+                <a:ea typeface="Noto Sans CJK JP"/>
+                <a:cs typeface="Noto Sans"/>
+              </a:rPr>
+              <a:t>英中のニュース翻訳を、BLEUと人手で評価する</a:t>
+            </a:r>
+          </a:p>
+        </p:txBody>
+      </p:sp>
+      <p:sp>
+        <p:nvSpPr>
+          <p:cNvPr id="3" name="Text Placeholder 2"/>
+          <p:cNvSpPr>
+            <a:spLocks noGrp="1"/>
+          </p:cNvSpPr>
+          <p:nvPr>
+            <p:ph type="body" idx="1"/>
+          </p:nvPr>
+        </p:nvSpPr>
+        <p:spPr>
+          <a:xfrm>
+            <a:off x="594360" y="1463040"/>
+            <a:ext cx="7955279" cy="3044952"/>
+          </a:xfrm>
+        </p:spPr>
+        <p:txBody>
+          <a:bodyPr wrap="square" tIns="91440" bIns="91440">
+            <a:noAutofit/>
+          </a:bodyPr>
+          <a:lstStyle/>
+          <a:p>
+            <a:pPr marL="457200" indent="-355600">
+              <a:lnSpc>
+                <a:spcPts val="2261"/>
+              </a:lnSpc>
+              <a:spcAft>
+                <a:spcPts val="700"/>
+              </a:spcAft>
+              <a:buSzPct val="70000"/>
+              <a:buFont typeface="Noto Sans CJK JP"/>
+              <a:buChar char="●"/>
+              <a:defRPr sz="1900" b="0">
+                <a:solidFill>
+                  <a:srgbClr val="303437"/>
+                </a:solidFill>
+                <a:latin typeface="Noto Sans"/>
+              </a:defRPr>
+            </a:pPr>
+            <a:r>
+              <a:rPr sz="1900" b="0" lang="ja-JP" altLang="en-US">
+                <a:solidFill>
+                  <a:srgbClr val="303437"/>
+                </a:solidFill>
+                <a:latin typeface="Noto Sans"/>
+                <a:ea typeface="Noto Sans CJK JP"/>
+                <a:cs typeface="Noto Sans"/>
+              </a:rPr>
+              <a:t>WMT2020の英中公開テストは、英語→中国語が1,418区間、中国語→英語が2,000区間。ニュースの原文に、人が作った参照訳が付く。</a:t>
+            </a:r>
+          </a:p>
+          <a:p>
+            <a:pPr marL="457200" indent="-355600">
+              <a:lnSpc>
+                <a:spcPts val="2261"/>
+              </a:lnSpc>
+              <a:spcAft>
+                <a:spcPts val="700"/>
+              </a:spcAft>
+              <a:buSzPct val="70000"/>
+              <a:buFont typeface="Noto Sans CJK JP"/>
+              <a:buChar char="●"/>
+              <a:defRPr sz="1900" b="0">
+                <a:solidFill>
+                  <a:srgbClr val="303437"/>
+                </a:solidFill>
+                <a:latin typeface="Noto Sans"/>
+              </a:defRPr>
+            </a:pPr>
+            <a:r>
+              <a:rPr sz="1900" b="0" lang="ja-JP" altLang="en-US">
+                <a:solidFill>
+                  <a:srgbClr val="303437"/>
+                </a:solidFill>
+                <a:latin typeface="Noto Sans"/>
+                <a:ea typeface="Noto Sans CJK JP"/>
+                <a:cs typeface="Noto Sans"/>
+              </a:rPr>
+              <a:t>BLEUは参照訳との語句の一致を測り、人手評価は文脈の中で意味が伝わるかを調べる。同じ入力にも異なる参照訳があり、語句の選び方がBLEUに影響する。</a:t>
+            </a:r>
+          </a:p>
+        </p:txBody>
+      </p:sp>
+      <p:sp>
+        <p:nvSpPr>
+          <p:cNvPr id="4" name="Title 3"/>
+          <p:cNvSpPr>
+            <a:spLocks noGrp="1"/>
+          </p:cNvSpPr>
+          <p:nvPr>
+            <p:ph type="title" idx="2"/>
+          </p:nvPr>
+        </p:nvSpPr>
+        <p:spPr>
+          <a:xfrm>
+            <a:off x="75895" y="0"/>
+            <a:ext cx="8115300" cy="480060"/>
+          </a:xfrm>
+        </p:spPr>
+        <p:txBody>
+          <a:bodyPr wrap="square" lIns="0" rIns="0" tIns="0" bIns="0" anchor="ctr">
+            <a:noAutofit/>
+          </a:bodyPr>
+          <a:lstStyle/>
+          <a:p>
+            <a:pPr algn="l">
+              <a:lnSpc>
+                <a:spcPct val="110000"/>
+              </a:lnSpc>
+              <a:buNone/>
+              <a:defRPr sz="1400" b="0">
+                <a:solidFill>
+                  <a:srgbClr val="303437"/>
+                </a:solidFill>
+                <a:latin typeface="Noto Sans"/>
+              </a:defRPr>
+            </a:pPr>
+            <a:r>
+              <a:rPr sz="1400" b="1" lang="ja-JP" altLang="en-US">
+                <a:solidFill>
+                  <a:srgbClr val="FFFEF8"/>
+                </a:solidFill>
+                <a:latin typeface="Noto Sans"/>
+                <a:ea typeface="Noto Sans CJK JP"/>
+                <a:cs typeface="Noto Sans"/>
+              </a:rPr>
+              <a:t>4. 入手と利用条件</a:t>
+            </a:r>
+          </a:p>
+        </p:txBody>
+      </p:sp>
+      <p:sp>
+        <p:nvSpPr>
+          <p:cNvPr id="5" name="sources"/>
+          <p:cNvSpPr txBox="1"/>
+          <p:nvPr/>
+        </p:nvSpPr>
+        <p:spPr>
+          <a:xfrm>
+            <a:off x="502920" y="4700016"/>
+            <a:ext cx="8183879" cy="530352"/>
+          </a:xfrm>
+          <a:prstGeom prst="rect">
+            <a:avLst/>
+          </a:prstGeom>
+          <a:noFill/>
+        </p:spPr>
+        <p:txBody>
+          <a:bodyPr wrap="square" lIns="0" rIns="0" tIns="0" bIns="0">
+            <a:noAutofit/>
+          </a:bodyPr>
+          <a:lstStyle/>
+          <a:p>
+            <a:pPr algn="l">
               <a:lnSpc>
                 <a:spcPts val="940"/>
               </a:lnSpc>
+              <a:spcBef>
+                <a:spcPts val="0"/>
+              </a:spcBef>
               <a:spcAft>
                 <a:spcPts val="300"/>
               </a:spcAft>
@@ -14700,25 +14921,8 @@
                 <a:ea typeface="Noto Sans CJK JP"/>
                 <a:cs typeface="Noto Sans"/>
               </a:rPr>
-              <a:t>[2] Stanford CRFM. CLEVATranslationScenario / Converter. HELM v0.4.0.</a:t>
-            </a:r>
-          </a:p>
-          <a:p>
-            <a:pPr>
-              <a:lnSpc>
-                <a:spcPts val="940"/>
-              </a:lnSpc>
-              <a:spcAft>
-                <a:spcPts val="300"/>
-              </a:spcAft>
-              <a:buNone/>
-              <a:defRPr sz="810" b="0">
-                <a:solidFill>
-                  <a:srgbClr val="303437"/>
-                </a:solidFill>
-                <a:latin typeface="Noto Sans"/>
-              </a:defRPr>
-            </a:pPr>
+              <a:t>[1] Barrault et al. (2020). Findings of the 2020 Conference on Machine Translation (WMT20). WMT, pp.1–55. </a:t>
+            </a:r>
             <a:r>
               <a:rPr sz="810" b="0" lang="ja-JP" altLang="en-US">
                 <a:solidFill>
@@ -14727,9 +14931,9 @@
                 <a:latin typeface="Noto Sans"/>
                 <a:ea typeface="Noto Sans CJK JP"/>
                 <a:cs typeface="Noto Sans"/>
-                <a:hlinkClick r:id="rId3"/>
-              </a:rPr>
-              <a:t>https://github.com/stanford-crfm/helm/blob/v0.4.0/src/helm/benchmark/scenarios/cleva_scenario.py</a:t>
+                <a:hlinkClick r:id="rId2"/>
+              </a:rPr>
+              <a:t>https://aclanthology.org/2020.wmt-1.1/</a:t>
             </a:r>
           </a:p>
         </p:txBody>
@@ -14764,128 +14968,45 @@
         </p:nvSpPr>
         <p:spPr>
           <a:xfrm>
-            <a:off x="468172" y="650138"/>
-            <a:ext cx="8206740" cy="616305"/>
+            <a:off x="548640" y="2484835"/>
+            <a:ext cx="8046720" cy="585216"/>
           </a:xfrm>
         </p:spPr>
         <p:txBody>
-          <a:bodyPr wrap="square" lIns="0" rIns="0" tIns="0" bIns="0">
+          <a:bodyPr wrap="square" lIns="0" rIns="0" tIns="0" bIns="0" anchor="ctr">
             <a:noAutofit/>
           </a:bodyPr>
           <a:lstStyle/>
           <a:p>
-            <a:pPr algn="l">
+            <a:pPr algn="ctr">
               <a:lnSpc>
                 <a:spcPct val="110000"/>
               </a:lnSpc>
               <a:buNone/>
-              <a:defRPr sz="2800" b="0">
-                <a:solidFill>
-                  <a:srgbClr val="303437"/>
-                </a:solidFill>
-                <a:latin typeface="Noto Sans"/>
-              </a:defRPr>
-            </a:pPr>
-            <a:r>
-              <a:rPr sz="2800" b="1" lang="ja-JP" altLang="en-US">
-                <a:solidFill>
-                  <a:srgbClr val="303437"/>
-                </a:solidFill>
-                <a:latin typeface="Noto Sans"/>
-                <a:ea typeface="Noto Sans CJK JP"/>
-                <a:cs typeface="Noto Sans"/>
-              </a:rPr>
-              <a:t>研究目的で利用でき、引用と権利の条件がある</a:t>
+              <a:defRPr sz="3600" b="0">
+                <a:solidFill>
+                  <a:srgbClr val="303437"/>
+                </a:solidFill>
+                <a:latin typeface="Noto Sans"/>
+              </a:defRPr>
+            </a:pPr>
+            <a:r>
+              <a:rPr sz="3600" b="1" lang="ja-JP" altLang="en-US">
+                <a:solidFill>
+                  <a:srgbClr val="303437"/>
+                </a:solidFill>
+                <a:latin typeface="Noto Sans"/>
+                <a:ea typeface="Noto Sans CJK JP"/>
+                <a:cs typeface="Noto Sans"/>
+              </a:rPr>
+              <a:t>Appendix</a:t>
             </a:r>
           </a:p>
         </p:txBody>
       </p:sp>
       <p:sp>
         <p:nvSpPr>
-          <p:cNvPr id="3" name="Text Placeholder 2"/>
-          <p:cNvSpPr>
-            <a:spLocks noGrp="1"/>
-          </p:cNvSpPr>
-          <p:nvPr>
-            <p:ph type="body" idx="1"/>
-          </p:nvPr>
-        </p:nvSpPr>
-        <p:spPr>
-          <a:xfrm>
-            <a:off x="594360" y="1463040"/>
-            <a:ext cx="7955279" cy="3044952"/>
-          </a:xfrm>
-        </p:spPr>
-        <p:txBody>
-          <a:bodyPr wrap="square" tIns="91440" bIns="91440">
-            <a:noAutofit/>
-          </a:bodyPr>
-          <a:lstStyle/>
-          <a:p>
-            <a:pPr marL="457200" indent="-355600">
-              <a:lnSpc>
-                <a:spcPts val="2320"/>
-              </a:lnSpc>
-              <a:spcAft>
-                <a:spcPts val="700"/>
-              </a:spcAft>
-              <a:buSzPct val="68205"/>
-              <a:buFont typeface="Noto Sans CJK JP"/>
-              <a:buChar char="●"/>
-              <a:defRPr sz="1950" b="0">
-                <a:solidFill>
-                  <a:srgbClr val="303437"/>
-                </a:solidFill>
-                <a:latin typeface="Noto Sans"/>
-              </a:defRPr>
-            </a:pPr>
-            <a:r>
-              <a:rPr sz="1950" b="0" lang="ja-JP" altLang="en-US">
-                <a:solidFill>
-                  <a:srgbClr val="303437"/>
-                </a:solidFill>
-                <a:latin typeface="Noto Sans"/>
-                <a:ea typeface="Noto Sans CJK JP"/>
-                <a:cs typeface="Noto Sans"/>
-              </a:rPr>
-              <a:t>公式タスクページは、WMT20のデータを研究目的で自由に使えるとし、概要論文と各集合の追加引用条件を守るよう求める。</a:t>
-            </a:r>
-          </a:p>
-          <a:p>
-            <a:pPr marL="457200" indent="-355600">
-              <a:lnSpc>
-                <a:spcPts val="2320"/>
-              </a:lnSpc>
-              <a:spcAft>
-                <a:spcPts val="700"/>
-              </a:spcAft>
-              <a:buSzPct val="68205"/>
-              <a:buFont typeface="Noto Sans CJK JP"/>
-              <a:buChar char="●"/>
-              <a:defRPr sz="1950" b="0">
-                <a:solidFill>
-                  <a:srgbClr val="303437"/>
-                </a:solidFill>
-                <a:latin typeface="Noto Sans"/>
-              </a:defRPr>
-            </a:pPr>
-            <a:r>
-              <a:rPr sz="1950" b="0" lang="ja-JP" altLang="en-US">
-                <a:solidFill>
-                  <a:srgbClr val="303437"/>
-                </a:solidFill>
-                <a:latin typeface="Noto Sans"/>
-                <a:ea typeface="Noto Sans CJK JP"/>
-                <a:cs typeface="Noto Sans"/>
-              </a:rPr>
-              <a:t>それ以外の用途については、元データの権利者へ相談する条件になっている。</a:t>
-            </a:r>
-          </a:p>
-        </p:txBody>
-      </p:sp>
-      <p:sp>
-        <p:nvSpPr>
-          <p:cNvPr id="4" name="Title 3"/>
+          <p:cNvPr id="3" name="Title 2"/>
           <p:cNvSpPr>
             <a:spLocks noGrp="1"/>
           </p:cNvSpPr>
@@ -14926,84 +15047,7 @@
                 <a:ea typeface="Noto Sans CJK JP"/>
                 <a:cs typeface="Noto Sans"/>
               </a:rPr>
-              <a:t>4. CLEVAでの採用と利用条件</a:t>
-            </a:r>
-          </a:p>
-        </p:txBody>
-      </p:sp>
-      <p:sp>
-        <p:nvSpPr>
-          <p:cNvPr id="5" name="sources"/>
-          <p:cNvSpPr txBox="1"/>
-          <p:nvPr/>
-        </p:nvSpPr>
-        <p:spPr>
-          <a:xfrm>
-            <a:off x="502920" y="4700016"/>
-            <a:ext cx="8183879" cy="530352"/>
-          </a:xfrm>
-          <a:prstGeom prst="rect">
-            <a:avLst/>
-          </a:prstGeom>
-          <a:noFill/>
-        </p:spPr>
-        <p:txBody>
-          <a:bodyPr wrap="square" lIns="0" rIns="0" tIns="0" bIns="0">
-            <a:noAutofit/>
-          </a:bodyPr>
-          <a:lstStyle/>
-          <a:p>
-            <a:pPr algn="l">
-              <a:lnSpc>
-                <a:spcPts val="940"/>
-              </a:lnSpc>
-              <a:spcBef>
-                <a:spcPts val="0"/>
-              </a:spcBef>
-              <a:spcAft>
-                <a:spcPts val="300"/>
-              </a:spcAft>
-              <a:buNone/>
-              <a:defRPr sz="810" b="0">
-                <a:solidFill>
-                  <a:srgbClr val="303437"/>
-                </a:solidFill>
-                <a:latin typeface="Noto Sans"/>
-              </a:defRPr>
-            </a:pPr>
-            <a:r>
-              <a:rPr sz="810" b="0" lang="ja-JP" altLang="en-US">
-                <a:solidFill>
-                  <a:srgbClr val="626669"/>
-                </a:solidFill>
-                <a:latin typeface="Noto Sans"/>
-                <a:ea typeface="Noto Sans CJK JP"/>
-                <a:cs typeface="Noto Sans"/>
-              </a:rPr>
-              <a:t>[1] WMT20. Shared Task: Machine Translation of News. Task, data and licensing.</a:t>
-            </a:r>
-            <a:r>
-              <a:rPr sz="810" b="0" lang="ja-JP" altLang="en-US">
-                <a:solidFill>
-                  <a:srgbClr val="626669"/>
-                </a:solidFill>
-                <a:latin typeface="Noto Sans"/>
-                <a:ea typeface="Noto Sans CJK JP"/>
-                <a:cs typeface="Noto Sans"/>
-              </a:rPr>
-              <a:t>  </a:t>
-            </a:r>
-            <a:r>
-              <a:rPr sz="810" b="0" lang="ja-JP" altLang="en-US">
-                <a:solidFill>
-                  <a:srgbClr val="626669"/>
-                </a:solidFill>
-                <a:latin typeface="Noto Sans"/>
-                <a:ea typeface="Noto Sans CJK JP"/>
-                <a:cs typeface="Noto Sans"/>
-                <a:hlinkClick r:id="rId2"/>
-              </a:rPr>
-              <a:t>https://www.statmt.org/wmt20/translation-task.html</a:t>
+              <a:t>Appendix</a:t>
             </a:r>
           </a:p>
         </p:txBody>
@@ -15069,7 +15113,7 @@
                 <a:ea typeface="Noto Sans CJK JP"/>
                 <a:cs typeface="Noto Sans"/>
               </a:rPr>
-              <a:t>英中のニュース翻訳を、BLEUと人手で評価する</a:t>
+              <a:t/>
             </a:r>
           </a:p>
         </p:txBody>
@@ -15086,103 +15130,103 @@
         </p:nvSpPr>
         <p:spPr>
           <a:xfrm>
-            <a:off x="594360" y="1463040"/>
-            <a:ext cx="7955279" cy="3044952"/>
+            <a:off x="640080" y="1972511"/>
+            <a:ext cx="7863840" cy="1744980"/>
           </a:xfrm>
         </p:spPr>
         <p:txBody>
-          <a:bodyPr wrap="square" tIns="91440" bIns="91440">
+          <a:bodyPr lIns="0" rIns="0" tIns="0" bIns="0">
             <a:noAutofit/>
           </a:bodyPr>
           <a:lstStyle/>
           <a:p>
-            <a:pPr marL="457200" indent="-355600">
-              <a:lnSpc>
-                <a:spcPts val="2261"/>
-              </a:lnSpc>
-              <a:spcAft>
-                <a:spcPts val="700"/>
-              </a:spcAft>
-              <a:buSzPct val="70000"/>
+            <a:pPr marL="457200" indent="-457200">
+              <a:lnSpc>
+                <a:spcPts val="3660"/>
+              </a:lnSpc>
+              <a:spcAft>
+                <a:spcPts val="1200"/>
+              </a:spcAft>
+              <a:buSzPct val="100000"/>
               <a:buFont typeface="Noto Sans CJK JP"/>
-              <a:buChar char="●"/>
-              <a:defRPr sz="1900" b="0">
-                <a:solidFill>
-                  <a:srgbClr val="303437"/>
-                </a:solidFill>
-                <a:latin typeface="Noto Sans"/>
-              </a:defRPr>
-            </a:pPr>
-            <a:r>
-              <a:rPr sz="1900" b="0" lang="ja-JP" altLang="en-US">
-                <a:solidFill>
-                  <a:srgbClr val="303437"/>
-                </a:solidFill>
-                <a:latin typeface="Noto Sans"/>
-                <a:ea typeface="Noto Sans CJK JP"/>
-                <a:cs typeface="Noto Sans"/>
-              </a:rPr>
-              <a:t>WMT2020の英中公開テストは、英語→中国語が1,418区間、中国語→英語が2,000区間。ニュースの原文に、人が作った参照訳が付く。</a:t>
-            </a:r>
-          </a:p>
-          <a:p>
-            <a:pPr marL="457200" indent="-355600">
-              <a:lnSpc>
-                <a:spcPts val="2261"/>
-              </a:lnSpc>
-              <a:spcAft>
-                <a:spcPts val="700"/>
-              </a:spcAft>
-              <a:buSzPct val="70000"/>
+              <a:buAutoNum type="arabicPeriod" startAt="1"/>
+              <a:defRPr sz="3000" b="1">
+                <a:solidFill>
+                  <a:srgbClr val="303437"/>
+                </a:solidFill>
+                <a:latin typeface="Noto Sans"/>
+              </a:defRPr>
+            </a:pPr>
+            <a:r>
+              <a:rPr sz="3000" b="1" lang="ja-JP" altLang="en-US">
+                <a:solidFill>
+                  <a:srgbClr val="303437"/>
+                </a:solidFill>
+                <a:latin typeface="Noto Sans"/>
+                <a:ea typeface="Noto Sans CJK JP"/>
+                <a:cs typeface="Noto Sans"/>
+              </a:rPr>
+              <a:t>追加の公開翻訳例</a:t>
+            </a:r>
+          </a:p>
+          <a:p>
+            <a:pPr marL="457200" indent="-457200">
+              <a:lnSpc>
+                <a:spcPts val="3660"/>
+              </a:lnSpc>
+              <a:spcAft>
+                <a:spcPts val="1200"/>
+              </a:spcAft>
+              <a:buSzPct val="100000"/>
               <a:buFont typeface="Noto Sans CJK JP"/>
-              <a:buChar char="●"/>
-              <a:defRPr sz="1900" b="0">
-                <a:solidFill>
-                  <a:srgbClr val="303437"/>
-                </a:solidFill>
-                <a:latin typeface="Noto Sans"/>
-              </a:defRPr>
-            </a:pPr>
-            <a:r>
-              <a:rPr sz="1900" b="0" lang="ja-JP" altLang="en-US">
-                <a:solidFill>
-                  <a:srgbClr val="303437"/>
-                </a:solidFill>
-                <a:latin typeface="Noto Sans"/>
-                <a:ea typeface="Noto Sans CJK JP"/>
-                <a:cs typeface="Noto Sans"/>
-              </a:rPr>
-              <a:t>BLEUは参照訳との語句の一致を測り、人手評価は文脈の中で意味が伝わるかを調べる。同じ入力にも異なる参照訳があり、語句の選び方がBLEUに影響する。</a:t>
-            </a:r>
-          </a:p>
-          <a:p>
-            <a:pPr marL="457200" indent="-355600">
-              <a:lnSpc>
-                <a:spcPts val="2261"/>
-              </a:lnSpc>
-              <a:spcAft>
-                <a:spcPts val="0"/>
-              </a:spcAft>
-              <a:buSzPct val="70000"/>
+              <a:buAutoNum type="arabicPeriod" startAt="2"/>
+              <a:defRPr sz="3000" b="1">
+                <a:solidFill>
+                  <a:srgbClr val="303437"/>
+                </a:solidFill>
+                <a:latin typeface="Noto Sans"/>
+              </a:defRPr>
+            </a:pPr>
+            <a:r>
+              <a:rPr sz="3000" b="1" lang="ja-JP" altLang="en-US">
+                <a:solidFill>
+                  <a:srgbClr val="303437"/>
+                </a:solidFill>
+                <a:latin typeface="Noto Sans"/>
+                <a:ea typeface="Noto Sans CJK JP"/>
+                <a:cs typeface="Noto Sans"/>
+              </a:rPr>
+              <a:t>データの読み方と評価の具体例</a:t>
+            </a:r>
+          </a:p>
+          <a:p>
+            <a:pPr marL="457200" indent="-457200">
+              <a:lnSpc>
+                <a:spcPts val="3660"/>
+              </a:lnSpc>
+              <a:spcAft>
+                <a:spcPts val="0"/>
+              </a:spcAft>
+              <a:buSzPct val="100000"/>
               <a:buFont typeface="Noto Sans CJK JP"/>
-              <a:buChar char="●"/>
-              <a:defRPr sz="1900" b="0">
-                <a:solidFill>
-                  <a:srgbClr val="303437"/>
-                </a:solidFill>
-                <a:latin typeface="Noto Sans"/>
-              </a:defRPr>
-            </a:pPr>
-            <a:r>
-              <a:rPr sz="1900" b="0" lang="ja-JP" altLang="en-US">
-                <a:solidFill>
-                  <a:srgbClr val="303437"/>
-                </a:solidFill>
-                <a:latin typeface="Noto Sans"/>
-                <a:ea typeface="Noto Sans CJK JP"/>
-                <a:cs typeface="Noto Sans"/>
-              </a:rPr>
-              <a:t>後にCLEVAでも、WMTのデータが言語モデルの翻訳評価へ取り込まれた。</a:t>
+              <a:buAutoNum type="arabicPeriod" startAt="3"/>
+              <a:defRPr sz="3000" b="1">
+                <a:solidFill>
+                  <a:srgbClr val="303437"/>
+                </a:solidFill>
+                <a:latin typeface="Noto Sans"/>
+              </a:defRPr>
+            </a:pPr>
+            <a:r>
+              <a:rPr sz="3000" b="1" lang="ja-JP" altLang="en-US">
+                <a:solidFill>
+                  <a:srgbClr val="303437"/>
+                </a:solidFill>
+                <a:latin typeface="Noto Sans"/>
+                <a:ea typeface="Noto Sans CJK JP"/>
+                <a:cs typeface="Noto Sans"/>
+              </a:rPr>
+              <a:t>参考文献</a:t>
             </a:r>
           </a:p>
         </p:txBody>
@@ -15230,135 +15274,7 @@
                 <a:ea typeface="Noto Sans CJK JP"/>
                 <a:cs typeface="Noto Sans"/>
               </a:rPr>
-              <a:t>4. CLEVAでの採用と利用条件</a:t>
-            </a:r>
-          </a:p>
-        </p:txBody>
-      </p:sp>
-      <p:sp>
-        <p:nvSpPr>
-          <p:cNvPr id="5" name="sources"/>
-          <p:cNvSpPr txBox="1"/>
-          <p:nvPr/>
-        </p:nvSpPr>
-        <p:spPr>
-          <a:xfrm>
-            <a:off x="502920" y="4700016"/>
-            <a:ext cx="8183879" cy="530352"/>
-          </a:xfrm>
-          <a:prstGeom prst="rect">
-            <a:avLst/>
-          </a:prstGeom>
-          <a:noFill/>
-        </p:spPr>
-        <p:txBody>
-          <a:bodyPr wrap="square" lIns="0" rIns="0" tIns="0" bIns="0">
-            <a:noAutofit/>
-          </a:bodyPr>
-          <a:lstStyle/>
-          <a:p>
-            <a:pPr algn="l">
-              <a:lnSpc>
-                <a:spcPts val="940"/>
-              </a:lnSpc>
-              <a:spcBef>
-                <a:spcPts val="0"/>
-              </a:spcBef>
-              <a:spcAft>
-                <a:spcPts val="300"/>
-              </a:spcAft>
-              <a:buNone/>
-              <a:defRPr sz="810" b="0">
-                <a:solidFill>
-                  <a:srgbClr val="303437"/>
-                </a:solidFill>
-                <a:latin typeface="Noto Sans"/>
-              </a:defRPr>
-            </a:pPr>
-            <a:r>
-              <a:rPr sz="810" b="0" lang="ja-JP" altLang="en-US">
-                <a:solidFill>
-                  <a:srgbClr val="626669"/>
-                </a:solidFill>
-                <a:latin typeface="Noto Sans"/>
-                <a:ea typeface="Noto Sans CJK JP"/>
-                <a:cs typeface="Noto Sans"/>
-              </a:rPr>
-              <a:t>[1] Barrault et al. (2020). Findings of the 2020 Conference on Machine Translation (WMT20). WMT, pp.1–55.</a:t>
-            </a:r>
-            <a:r>
-              <a:rPr sz="810" b="0" lang="ja-JP" altLang="en-US">
-                <a:solidFill>
-                  <a:srgbClr val="626669"/>
-                </a:solidFill>
-                <a:latin typeface="Noto Sans"/>
-                <a:ea typeface="Noto Sans CJK JP"/>
-                <a:cs typeface="Noto Sans"/>
-              </a:rPr>
-              <a:t>  </a:t>
-            </a:r>
-            <a:r>
-              <a:rPr sz="810" b="0" lang="ja-JP" altLang="en-US">
-                <a:solidFill>
-                  <a:srgbClr val="626669"/>
-                </a:solidFill>
-                <a:latin typeface="Noto Sans"/>
-                <a:ea typeface="Noto Sans CJK JP"/>
-                <a:cs typeface="Noto Sans"/>
-                <a:hlinkClick r:id="rId2"/>
-              </a:rPr>
-              <a:t>https://aclanthology.org/2020.wmt-1.1/</a:t>
-            </a:r>
-          </a:p>
-          <a:p>
-            <a:pPr>
-              <a:lnSpc>
-                <a:spcPts val="940"/>
-              </a:lnSpc>
-              <a:spcAft>
-                <a:spcPts val="300"/>
-              </a:spcAft>
-              <a:buNone/>
-              <a:defRPr sz="810" b="0">
-                <a:solidFill>
-                  <a:srgbClr val="303437"/>
-                </a:solidFill>
-                <a:latin typeface="Noto Sans"/>
-              </a:defRPr>
-            </a:pPr>
-            <a:r>
-              <a:rPr sz="810" b="0" lang="ja-JP" altLang="en-US">
-                <a:solidFill>
-                  <a:srgbClr val="626669"/>
-                </a:solidFill>
-                <a:latin typeface="Noto Sans"/>
-                <a:ea typeface="Noto Sans CJK JP"/>
-                <a:cs typeface="Noto Sans"/>
-              </a:rPr>
-              <a:t>[2] Li et al. (2023). CLEVA: Chinese Language Models EVAluation Platform. EMNLP System Demonstrations.</a:t>
-            </a:r>
-            <a:r>
-              <a:rPr sz="810" b="0" lang="ja-JP" altLang="en-US">
-                <a:solidFill>
-                  <a:srgbClr val="626669"/>
-                </a:solidFill>
-                <a:latin typeface="Noto Sans"/>
-                <a:ea typeface="Noto Sans CJK JP"/>
-                <a:cs typeface="Noto Sans"/>
-              </a:rPr>
-              <a:t>  </a:t>
-            </a:r>
-            <a:r>
-              <a:rPr sz="810" b="0" lang="ja-JP" altLang="en-US">
-                <a:solidFill>
-                  <a:srgbClr val="626669"/>
-                </a:solidFill>
-                <a:latin typeface="Noto Sans"/>
-                <a:ea typeface="Noto Sans CJK JP"/>
-                <a:cs typeface="Noto Sans"/>
-                <a:hlinkClick r:id="rId3"/>
-              </a:rPr>
-              <a:t>https://aclanthology.org/2023.emnlp-demo.17/</a:t>
+              <a:t>Appendix: 目次</a:t>
             </a:r>
           </a:p>
         </p:txBody>
@@ -15567,7 +15483,7 @@
                 <a:ea typeface="Noto Sans CJK JP"/>
                 <a:cs typeface="Noto Sans"/>
               </a:rPr>
-              <a:t>CLEVAでの採用と利用条件</a:t>
+              <a:t>入手と利用条件</a:t>
             </a:r>
           </a:p>
         </p:txBody>
@@ -15650,7 +15566,7 @@
         </p:nvSpPr>
         <p:spPr>
           <a:xfrm>
-            <a:off x="548640" y="2484835"/>
+            <a:off x="548640" y="2506875"/>
             <a:ext cx="8046720" cy="585216"/>
           </a:xfrm>
         </p:spPr>
@@ -15681,7 +15597,7 @@
                 <a:ea typeface="Noto Sans CJK JP"/>
                 <a:cs typeface="Noto Sans"/>
               </a:rPr>
-              <a:t>Appendix</a:t>
+              <a:t>追加の公開翻訳例</a:t>
             </a:r>
           </a:p>
         </p:txBody>
@@ -15729,7 +15645,7 @@
                 <a:ea typeface="Noto Sans CJK JP"/>
                 <a:cs typeface="Noto Sans"/>
               </a:rPr>
-              <a:t>Appendix</a:t>
+              <a:t>Appendix: 1. 追加の公開翻訳例</a:t>
             </a:r>
           </a:p>
         </p:txBody>
@@ -15743,347 +15659,6 @@
 </file>
 
 <file path=ppt/slides/slide31.xml><?xml version="1.0" encoding="utf-8"?>
-<p:sld xmlns:a="http://schemas.openxmlformats.org/drawingml/2006/main" xmlns:p="http://schemas.openxmlformats.org/presentationml/2006/main" xmlns:r="http://schemas.openxmlformats.org/officeDocument/2006/relationships">
-  <p:cSld>
-    <p:spTree>
-      <p:nvGrpSpPr>
-        <p:cNvPr id="1" name=""/>
-        <p:cNvGrpSpPr/>
-        <p:nvPr/>
-      </p:nvGrpSpPr>
-      <p:grpSpPr/>
-      <p:sp>
-        <p:nvSpPr>
-          <p:cNvPr id="2" name="Title 1"/>
-          <p:cNvSpPr>
-            <a:spLocks noGrp="1"/>
-          </p:cNvSpPr>
-          <p:nvPr>
-            <p:ph type="title"/>
-          </p:nvPr>
-        </p:nvSpPr>
-        <p:spPr>
-          <a:xfrm>
-            <a:off x="468172" y="650138"/>
-            <a:ext cx="8206740" cy="616305"/>
-          </a:xfrm>
-        </p:spPr>
-        <p:txBody>
-          <a:bodyPr wrap="square" lIns="0" rIns="0" tIns="0" bIns="0">
-            <a:noAutofit/>
-          </a:bodyPr>
-          <a:lstStyle/>
-          <a:p>
-            <a:pPr algn="l">
-              <a:lnSpc>
-                <a:spcPct val="110000"/>
-              </a:lnSpc>
-              <a:buNone/>
-              <a:defRPr sz="2800" b="0">
-                <a:solidFill>
-                  <a:srgbClr val="303437"/>
-                </a:solidFill>
-                <a:latin typeface="Noto Sans"/>
-              </a:defRPr>
-            </a:pPr>
-            <a:r>
-              <a:rPr sz="2800" b="1" lang="ja-JP" altLang="en-US">
-                <a:solidFill>
-                  <a:srgbClr val="303437"/>
-                </a:solidFill>
-                <a:latin typeface="Noto Sans"/>
-                <a:ea typeface="Noto Sans CJK JP"/>
-                <a:cs typeface="Noto Sans"/>
-              </a:rPr>
-              <a:t/>
-            </a:r>
-          </a:p>
-        </p:txBody>
-      </p:sp>
-      <p:sp>
-        <p:nvSpPr>
-          <p:cNvPr id="3" name="Text Placeholder 2"/>
-          <p:cNvSpPr>
-            <a:spLocks noGrp="1"/>
-          </p:cNvSpPr>
-          <p:nvPr>
-            <p:ph type="body" idx="1"/>
-          </p:nvPr>
-        </p:nvSpPr>
-        <p:spPr>
-          <a:xfrm>
-            <a:off x="640080" y="1972511"/>
-            <a:ext cx="7863840" cy="1744980"/>
-          </a:xfrm>
-        </p:spPr>
-        <p:txBody>
-          <a:bodyPr lIns="0" rIns="0" tIns="0" bIns="0">
-            <a:noAutofit/>
-          </a:bodyPr>
-          <a:lstStyle/>
-          <a:p>
-            <a:pPr marL="457200" indent="-457200">
-              <a:lnSpc>
-                <a:spcPts val="3660"/>
-              </a:lnSpc>
-              <a:spcAft>
-                <a:spcPts val="1200"/>
-              </a:spcAft>
-              <a:buSzPct val="100000"/>
-              <a:buFont typeface="Noto Sans CJK JP"/>
-              <a:buAutoNum type="arabicPeriod" startAt="1"/>
-              <a:defRPr sz="3000" b="1">
-                <a:solidFill>
-                  <a:srgbClr val="303437"/>
-                </a:solidFill>
-                <a:latin typeface="Noto Sans"/>
-              </a:defRPr>
-            </a:pPr>
-            <a:r>
-              <a:rPr sz="3000" b="1" lang="ja-JP" altLang="en-US">
-                <a:solidFill>
-                  <a:srgbClr val="303437"/>
-                </a:solidFill>
-                <a:latin typeface="Noto Sans"/>
-                <a:ea typeface="Noto Sans CJK JP"/>
-                <a:cs typeface="Noto Sans"/>
-              </a:rPr>
-              <a:t>追加の公開翻訳例</a:t>
-            </a:r>
-          </a:p>
-          <a:p>
-            <a:pPr marL="457200" indent="-457200">
-              <a:lnSpc>
-                <a:spcPts val="3660"/>
-              </a:lnSpc>
-              <a:spcAft>
-                <a:spcPts val="1200"/>
-              </a:spcAft>
-              <a:buSzPct val="100000"/>
-              <a:buFont typeface="Noto Sans CJK JP"/>
-              <a:buAutoNum type="arabicPeriod" startAt="2"/>
-              <a:defRPr sz="3000" b="1">
-                <a:solidFill>
-                  <a:srgbClr val="303437"/>
-                </a:solidFill>
-                <a:latin typeface="Noto Sans"/>
-              </a:defRPr>
-            </a:pPr>
-            <a:r>
-              <a:rPr sz="3000" b="1" lang="ja-JP" altLang="en-US">
-                <a:solidFill>
-                  <a:srgbClr val="303437"/>
-                </a:solidFill>
-                <a:latin typeface="Noto Sans"/>
-                <a:ea typeface="Noto Sans CJK JP"/>
-                <a:cs typeface="Noto Sans"/>
-              </a:rPr>
-              <a:t>データの読み方と評価の具体例</a:t>
-            </a:r>
-          </a:p>
-          <a:p>
-            <a:pPr marL="457200" indent="-457200">
-              <a:lnSpc>
-                <a:spcPts val="3660"/>
-              </a:lnSpc>
-              <a:spcAft>
-                <a:spcPts val="0"/>
-              </a:spcAft>
-              <a:buSzPct val="100000"/>
-              <a:buFont typeface="Noto Sans CJK JP"/>
-              <a:buAutoNum type="arabicPeriod" startAt="3"/>
-              <a:defRPr sz="3000" b="1">
-                <a:solidFill>
-                  <a:srgbClr val="303437"/>
-                </a:solidFill>
-                <a:latin typeface="Noto Sans"/>
-              </a:defRPr>
-            </a:pPr>
-            <a:r>
-              <a:rPr sz="3000" b="1" lang="ja-JP" altLang="en-US">
-                <a:solidFill>
-                  <a:srgbClr val="303437"/>
-                </a:solidFill>
-                <a:latin typeface="Noto Sans"/>
-                <a:ea typeface="Noto Sans CJK JP"/>
-                <a:cs typeface="Noto Sans"/>
-              </a:rPr>
-              <a:t>参考文献</a:t>
-            </a:r>
-          </a:p>
-        </p:txBody>
-      </p:sp>
-      <p:sp>
-        <p:nvSpPr>
-          <p:cNvPr id="4" name="Title 3"/>
-          <p:cNvSpPr>
-            <a:spLocks noGrp="1"/>
-          </p:cNvSpPr>
-          <p:nvPr>
-            <p:ph type="title" idx="2"/>
-          </p:nvPr>
-        </p:nvSpPr>
-        <p:spPr>
-          <a:xfrm>
-            <a:off x="75895" y="0"/>
-            <a:ext cx="8115300" cy="480060"/>
-          </a:xfrm>
-        </p:spPr>
-        <p:txBody>
-          <a:bodyPr wrap="square" lIns="0" rIns="0" tIns="0" bIns="0" anchor="ctr">
-            <a:noAutofit/>
-          </a:bodyPr>
-          <a:lstStyle/>
-          <a:p>
-            <a:pPr algn="l">
-              <a:lnSpc>
-                <a:spcPct val="110000"/>
-              </a:lnSpc>
-              <a:buNone/>
-              <a:defRPr sz="1400" b="0">
-                <a:solidFill>
-                  <a:srgbClr val="303437"/>
-                </a:solidFill>
-                <a:latin typeface="Noto Sans"/>
-              </a:defRPr>
-            </a:pPr>
-            <a:r>
-              <a:rPr sz="1400" b="1" lang="ja-JP" altLang="en-US">
-                <a:solidFill>
-                  <a:srgbClr val="FFFEF8"/>
-                </a:solidFill>
-                <a:latin typeface="Noto Sans"/>
-                <a:ea typeface="Noto Sans CJK JP"/>
-                <a:cs typeface="Noto Sans"/>
-              </a:rPr>
-              <a:t>Appendix: 目次</a:t>
-            </a:r>
-          </a:p>
-        </p:txBody>
-      </p:sp>
-    </p:spTree>
-  </p:cSld>
-  <p:clrMapOvr>
-    <a:masterClrMapping/>
-  </p:clrMapOvr>
-</p:sld>
-</file>
-
-<file path=ppt/slides/slide32.xml><?xml version="1.0" encoding="utf-8"?>
-<p:sld xmlns:a="http://schemas.openxmlformats.org/drawingml/2006/main" xmlns:p="http://schemas.openxmlformats.org/presentationml/2006/main" xmlns:r="http://schemas.openxmlformats.org/officeDocument/2006/relationships">
-  <p:cSld>
-    <p:spTree>
-      <p:nvGrpSpPr>
-        <p:cNvPr id="1" name=""/>
-        <p:cNvGrpSpPr/>
-        <p:nvPr/>
-      </p:nvGrpSpPr>
-      <p:grpSpPr/>
-      <p:sp>
-        <p:nvSpPr>
-          <p:cNvPr id="2" name="Title 1"/>
-          <p:cNvSpPr>
-            <a:spLocks noGrp="1"/>
-          </p:cNvSpPr>
-          <p:nvPr>
-            <p:ph type="title"/>
-          </p:nvPr>
-        </p:nvSpPr>
-        <p:spPr>
-          <a:xfrm>
-            <a:off x="548640" y="2506875"/>
-            <a:ext cx="8046720" cy="585216"/>
-          </a:xfrm>
-        </p:spPr>
-        <p:txBody>
-          <a:bodyPr wrap="square" lIns="0" rIns="0" tIns="0" bIns="0" anchor="ctr">
-            <a:noAutofit/>
-          </a:bodyPr>
-          <a:lstStyle/>
-          <a:p>
-            <a:pPr algn="ctr">
-              <a:lnSpc>
-                <a:spcPct val="110000"/>
-              </a:lnSpc>
-              <a:buNone/>
-              <a:defRPr sz="3600" b="0">
-                <a:solidFill>
-                  <a:srgbClr val="303437"/>
-                </a:solidFill>
-                <a:latin typeface="Noto Sans"/>
-              </a:defRPr>
-            </a:pPr>
-            <a:r>
-              <a:rPr sz="3600" b="1" lang="ja-JP" altLang="en-US">
-                <a:solidFill>
-                  <a:srgbClr val="303437"/>
-                </a:solidFill>
-                <a:latin typeface="Noto Sans"/>
-                <a:ea typeface="Noto Sans CJK JP"/>
-                <a:cs typeface="Noto Sans"/>
-              </a:rPr>
-              <a:t>追加の公開翻訳例</a:t>
-            </a:r>
-          </a:p>
-        </p:txBody>
-      </p:sp>
-      <p:sp>
-        <p:nvSpPr>
-          <p:cNvPr id="3" name="Title 2"/>
-          <p:cNvSpPr>
-            <a:spLocks noGrp="1"/>
-          </p:cNvSpPr>
-          <p:nvPr>
-            <p:ph type="title" idx="2"/>
-          </p:nvPr>
-        </p:nvSpPr>
-        <p:spPr>
-          <a:xfrm>
-            <a:off x="75895" y="0"/>
-            <a:ext cx="8115300" cy="480060"/>
-          </a:xfrm>
-        </p:spPr>
-        <p:txBody>
-          <a:bodyPr wrap="square" lIns="0" rIns="0" tIns="0" bIns="0" anchor="ctr">
-            <a:noAutofit/>
-          </a:bodyPr>
-          <a:lstStyle/>
-          <a:p>
-            <a:pPr algn="l">
-              <a:lnSpc>
-                <a:spcPct val="110000"/>
-              </a:lnSpc>
-              <a:buNone/>
-              <a:defRPr sz="1400" b="0">
-                <a:solidFill>
-                  <a:srgbClr val="303437"/>
-                </a:solidFill>
-                <a:latin typeface="Noto Sans"/>
-              </a:defRPr>
-            </a:pPr>
-            <a:r>
-              <a:rPr sz="1400" b="1" lang="ja-JP" altLang="en-US">
-                <a:solidFill>
-                  <a:srgbClr val="FFFEF8"/>
-                </a:solidFill>
-                <a:latin typeface="Noto Sans"/>
-                <a:ea typeface="Noto Sans CJK JP"/>
-                <a:cs typeface="Noto Sans"/>
-              </a:rPr>
-              <a:t>Appendix: 1. 追加の公開翻訳例</a:t>
-            </a:r>
-          </a:p>
-        </p:txBody>
-      </p:sp>
-    </p:spTree>
-  </p:cSld>
-  <p:clrMapOvr>
-    <a:masterClrMapping/>
-  </p:clrMapOvr>
-</p:sld>
-</file>
-
-<file path=ppt/slides/slide33.xml><?xml version="1.0" encoding="utf-8"?>
 <p:sld xmlns:a="http://schemas.openxmlformats.org/drawingml/2006/main" xmlns:p="http://schemas.openxmlformats.org/presentationml/2006/main" xmlns:r="http://schemas.openxmlformats.org/officeDocument/2006/relationships">
   <p:cSld>
     <p:spTree>
@@ -16651,7 +16226,7 @@
 </p:sld>
 </file>
 
-<file path=ppt/slides/slide34.xml><?xml version="1.0" encoding="utf-8"?>
+<file path=ppt/slides/slide32.xml><?xml version="1.0" encoding="utf-8"?>
 <p:sld xmlns:a="http://schemas.openxmlformats.org/drawingml/2006/main" xmlns:p="http://schemas.openxmlformats.org/presentationml/2006/main" xmlns:r="http://schemas.openxmlformats.org/officeDocument/2006/relationships">
   <p:cSld>
     <p:spTree>
@@ -17219,7 +16794,7 @@
 </p:sld>
 </file>
 
-<file path=ppt/slides/slide35.xml><?xml version="1.0" encoding="utf-8"?>
+<file path=ppt/slides/slide33.xml><?xml version="1.0" encoding="utf-8"?>
 <p:sld xmlns:a="http://schemas.openxmlformats.org/drawingml/2006/main" xmlns:p="http://schemas.openxmlformats.org/presentationml/2006/main" xmlns:r="http://schemas.openxmlformats.org/officeDocument/2006/relationships">
   <p:cSld>
     <p:spTree>
@@ -17787,7 +17362,7 @@
 </p:sld>
 </file>
 
-<file path=ppt/slides/slide36.xml><?xml version="1.0" encoding="utf-8"?>
+<file path=ppt/slides/slide34.xml><?xml version="1.0" encoding="utf-8"?>
 <p:sld xmlns:a="http://schemas.openxmlformats.org/drawingml/2006/main" xmlns:p="http://schemas.openxmlformats.org/presentationml/2006/main" xmlns:r="http://schemas.openxmlformats.org/officeDocument/2006/relationships">
   <p:cSld>
     <p:spTree>
@@ -18355,7 +17930,7 @@
 </p:sld>
 </file>
 
-<file path=ppt/slides/slide37.xml><?xml version="1.0" encoding="utf-8"?>
+<file path=ppt/slides/slide35.xml><?xml version="1.0" encoding="utf-8"?>
 <p:sld xmlns:a="http://schemas.openxmlformats.org/drawingml/2006/main" xmlns:p="http://schemas.openxmlformats.org/presentationml/2006/main" xmlns:r="http://schemas.openxmlformats.org/officeDocument/2006/relationships">
   <p:cSld>
     <p:spTree>
@@ -18923,7 +18498,7 @@
 </p:sld>
 </file>
 
-<file path=ppt/slides/slide38.xml><?xml version="1.0" encoding="utf-8"?>
+<file path=ppt/slides/slide36.xml><?xml version="1.0" encoding="utf-8"?>
 <p:sld xmlns:a="http://schemas.openxmlformats.org/drawingml/2006/main" xmlns:p="http://schemas.openxmlformats.org/presentationml/2006/main" xmlns:r="http://schemas.openxmlformats.org/officeDocument/2006/relationships">
   <p:cSld>
     <p:spTree>
@@ -19491,7 +19066,7 @@
 </p:sld>
 </file>
 
-<file path=ppt/slides/slide39.xml><?xml version="1.0" encoding="utf-8"?>
+<file path=ppt/slides/slide37.xml><?xml version="1.0" encoding="utf-8"?>
 <p:sld xmlns:a="http://schemas.openxmlformats.org/drawingml/2006/main" xmlns:p="http://schemas.openxmlformats.org/presentationml/2006/main" xmlns:r="http://schemas.openxmlformats.org/officeDocument/2006/relationships">
   <p:cSld>
     <p:spTree>
@@ -20059,121 +19634,7 @@
 </p:sld>
 </file>
 
-<file path=ppt/slides/slide4.xml><?xml version="1.0" encoding="utf-8"?>
-<p:sld xmlns:a="http://schemas.openxmlformats.org/drawingml/2006/main" xmlns:p="http://schemas.openxmlformats.org/presentationml/2006/main" xmlns:r="http://schemas.openxmlformats.org/officeDocument/2006/relationships">
-  <p:cSld>
-    <p:spTree>
-      <p:nvGrpSpPr>
-        <p:cNvPr id="1" name=""/>
-        <p:cNvGrpSpPr/>
-        <p:nvPr/>
-      </p:nvGrpSpPr>
-      <p:grpSpPr/>
-      <p:sp>
-        <p:nvSpPr>
-          <p:cNvPr id="2" name="Title 1"/>
-          <p:cNvSpPr>
-            <a:spLocks noGrp="1"/>
-          </p:cNvSpPr>
-          <p:nvPr>
-            <p:ph type="title"/>
-          </p:nvPr>
-        </p:nvSpPr>
-        <p:spPr>
-          <a:xfrm>
-            <a:off x="548640" y="2506875"/>
-            <a:ext cx="8046720" cy="585216"/>
-          </a:xfrm>
-        </p:spPr>
-        <p:txBody>
-          <a:bodyPr wrap="square" lIns="0" rIns="0" tIns="0" bIns="0" anchor="ctr">
-            <a:noAutofit/>
-          </a:bodyPr>
-          <a:lstStyle/>
-          <a:p>
-            <a:pPr algn="ctr">
-              <a:lnSpc>
-                <a:spcPct val="110000"/>
-              </a:lnSpc>
-              <a:buNone/>
-              <a:defRPr sz="3600" b="0">
-                <a:solidFill>
-                  <a:srgbClr val="303437"/>
-                </a:solidFill>
-                <a:latin typeface="Noto Sans"/>
-              </a:defRPr>
-            </a:pPr>
-            <a:r>
-              <a:rPr sz="3600" b="1" lang="ja-JP" altLang="en-US">
-                <a:solidFill>
-                  <a:srgbClr val="303437"/>
-                </a:solidFill>
-                <a:latin typeface="Noto Sans"/>
-                <a:ea typeface="Noto Sans CJK JP"/>
-                <a:cs typeface="Noto Sans"/>
-              </a:rPr>
-              <a:t>原文の内容を、もう一つの言語へ</a:t>
-            </a:r>
-          </a:p>
-        </p:txBody>
-      </p:sp>
-      <p:sp>
-        <p:nvSpPr>
-          <p:cNvPr id="3" name="Title 2"/>
-          <p:cNvSpPr>
-            <a:spLocks noGrp="1"/>
-          </p:cNvSpPr>
-          <p:nvPr>
-            <p:ph type="title" idx="2"/>
-          </p:nvPr>
-        </p:nvSpPr>
-        <p:spPr>
-          <a:xfrm>
-            <a:off x="75895" y="0"/>
-            <a:ext cx="8115300" cy="480060"/>
-          </a:xfrm>
-        </p:spPr>
-        <p:txBody>
-          <a:bodyPr wrap="square" lIns="0" rIns="0" tIns="0" bIns="0" anchor="ctr">
-            <a:noAutofit/>
-          </a:bodyPr>
-          <a:lstStyle/>
-          <a:p>
-            <a:pPr algn="l">
-              <a:lnSpc>
-                <a:spcPct val="110000"/>
-              </a:lnSpc>
-              <a:buNone/>
-              <a:defRPr sz="1400" b="0">
-                <a:solidFill>
-                  <a:srgbClr val="303437"/>
-                </a:solidFill>
-                <a:latin typeface="Noto Sans"/>
-              </a:defRPr>
-            </a:pPr>
-            <a:r>
-              <a:rPr sz="1400" b="1" lang="ja-JP" altLang="en-US">
-                <a:solidFill>
-                  <a:srgbClr val="FFFEF8"/>
-                </a:solidFill>
-                <a:latin typeface="Noto Sans"/>
-                <a:ea typeface="Noto Sans CJK JP"/>
-                <a:cs typeface="Noto Sans"/>
-              </a:rPr>
-              <a:t>1. ニュースを、別の言語へ訳す</a:t>
-            </a:r>
-          </a:p>
-        </p:txBody>
-      </p:sp>
-    </p:spTree>
-  </p:cSld>
-  <p:clrMapOvr>
-    <a:masterClrMapping/>
-  </p:clrMapOvr>
-</p:sld>
-</file>
-
-<file path=ppt/slides/slide40.xml><?xml version="1.0" encoding="utf-8"?>
+<file path=ppt/slides/slide38.xml><?xml version="1.0" encoding="utf-8"?>
 <p:sld xmlns:a="http://schemas.openxmlformats.org/drawingml/2006/main" xmlns:p="http://schemas.openxmlformats.org/presentationml/2006/main" xmlns:r="http://schemas.openxmlformats.org/officeDocument/2006/relationships">
   <p:cSld>
     <p:spTree>
@@ -20741,7 +20202,7 @@
 </p:sld>
 </file>
 
-<file path=ppt/slides/slide41.xml><?xml version="1.0" encoding="utf-8"?>
+<file path=ppt/slides/slide39.xml><?xml version="1.0" encoding="utf-8"?>
 <p:sld xmlns:a="http://schemas.openxmlformats.org/drawingml/2006/main" xmlns:p="http://schemas.openxmlformats.org/presentationml/2006/main" xmlns:r="http://schemas.openxmlformats.org/officeDocument/2006/relationships">
   <p:cSld>
     <p:spTree>
@@ -21309,7 +20770,121 @@
 </p:sld>
 </file>
 
-<file path=ppt/slides/slide42.xml><?xml version="1.0" encoding="utf-8"?>
+<file path=ppt/slides/slide4.xml><?xml version="1.0" encoding="utf-8"?>
+<p:sld xmlns:a="http://schemas.openxmlformats.org/drawingml/2006/main" xmlns:p="http://schemas.openxmlformats.org/presentationml/2006/main" xmlns:r="http://schemas.openxmlformats.org/officeDocument/2006/relationships">
+  <p:cSld>
+    <p:spTree>
+      <p:nvGrpSpPr>
+        <p:cNvPr id="1" name=""/>
+        <p:cNvGrpSpPr/>
+        <p:nvPr/>
+      </p:nvGrpSpPr>
+      <p:grpSpPr/>
+      <p:sp>
+        <p:nvSpPr>
+          <p:cNvPr id="2" name="Title 1"/>
+          <p:cNvSpPr>
+            <a:spLocks noGrp="1"/>
+          </p:cNvSpPr>
+          <p:nvPr>
+            <p:ph type="title"/>
+          </p:nvPr>
+        </p:nvSpPr>
+        <p:spPr>
+          <a:xfrm>
+            <a:off x="548640" y="2506875"/>
+            <a:ext cx="8046720" cy="585216"/>
+          </a:xfrm>
+        </p:spPr>
+        <p:txBody>
+          <a:bodyPr wrap="square" lIns="0" rIns="0" tIns="0" bIns="0" anchor="ctr">
+            <a:noAutofit/>
+          </a:bodyPr>
+          <a:lstStyle/>
+          <a:p>
+            <a:pPr algn="ctr">
+              <a:lnSpc>
+                <a:spcPct val="110000"/>
+              </a:lnSpc>
+              <a:buNone/>
+              <a:defRPr sz="3600" b="0">
+                <a:solidFill>
+                  <a:srgbClr val="303437"/>
+                </a:solidFill>
+                <a:latin typeface="Noto Sans"/>
+              </a:defRPr>
+            </a:pPr>
+            <a:r>
+              <a:rPr sz="3600" b="1" lang="ja-JP" altLang="en-US">
+                <a:solidFill>
+                  <a:srgbClr val="303437"/>
+                </a:solidFill>
+                <a:latin typeface="Noto Sans"/>
+                <a:ea typeface="Noto Sans CJK JP"/>
+                <a:cs typeface="Noto Sans"/>
+              </a:rPr>
+              <a:t>原文の内容を、もう一つの言語へ</a:t>
+            </a:r>
+          </a:p>
+        </p:txBody>
+      </p:sp>
+      <p:sp>
+        <p:nvSpPr>
+          <p:cNvPr id="3" name="Title 2"/>
+          <p:cNvSpPr>
+            <a:spLocks noGrp="1"/>
+          </p:cNvSpPr>
+          <p:nvPr>
+            <p:ph type="title" idx="2"/>
+          </p:nvPr>
+        </p:nvSpPr>
+        <p:spPr>
+          <a:xfrm>
+            <a:off x="75895" y="0"/>
+            <a:ext cx="8115300" cy="480060"/>
+          </a:xfrm>
+        </p:spPr>
+        <p:txBody>
+          <a:bodyPr wrap="square" lIns="0" rIns="0" tIns="0" bIns="0" anchor="ctr">
+            <a:noAutofit/>
+          </a:bodyPr>
+          <a:lstStyle/>
+          <a:p>
+            <a:pPr algn="l">
+              <a:lnSpc>
+                <a:spcPct val="110000"/>
+              </a:lnSpc>
+              <a:buNone/>
+              <a:defRPr sz="1400" b="0">
+                <a:solidFill>
+                  <a:srgbClr val="303437"/>
+                </a:solidFill>
+                <a:latin typeface="Noto Sans"/>
+              </a:defRPr>
+            </a:pPr>
+            <a:r>
+              <a:rPr sz="1400" b="1" lang="ja-JP" altLang="en-US">
+                <a:solidFill>
+                  <a:srgbClr val="FFFEF8"/>
+                </a:solidFill>
+                <a:latin typeface="Noto Sans"/>
+                <a:ea typeface="Noto Sans CJK JP"/>
+                <a:cs typeface="Noto Sans"/>
+              </a:rPr>
+              <a:t>1. ニュースを、別の言語へ訳す</a:t>
+            </a:r>
+          </a:p>
+        </p:txBody>
+      </p:sp>
+    </p:spTree>
+  </p:cSld>
+  <p:clrMapOvr>
+    <a:masterClrMapping/>
+  </p:clrMapOvr>
+</p:sld>
+</file>
+
+<file path=ppt/slides/slide40.xml><?xml version="1.0" encoding="utf-8"?>
 <p:sld xmlns:a="http://schemas.openxmlformats.org/drawingml/2006/main" xmlns:p="http://schemas.openxmlformats.org/presentationml/2006/main" xmlns:r="http://schemas.openxmlformats.org/officeDocument/2006/relationships">
   <p:cSld>
     <p:spTree>
@@ -21877,7 +21452,7 @@
 </p:sld>
 </file>
 
-<file path=ppt/slides/slide44.xml><?xml version="1.0" encoding="utf-8"?>
+<file path=ppt/slides/slide41.xml><?xml version="1.0" encoding="utf-8"?>
 <p:sld xmlns:a="http://schemas.openxmlformats.org/drawingml/2006/main" xmlns:p="http://schemas.openxmlformats.org/presentationml/2006/main" xmlns:r="http://schemas.openxmlformats.org/officeDocument/2006/relationships">
   <p:cSld>
     <p:spTree>
@@ -22728,7 +22303,7 @@
 </p:sld>
 </file>
 
-<file path=ppt/slides/slide46.xml><?xml version="1.0" encoding="utf-8"?>
+<file path=ppt/slides/slide42.xml><?xml version="1.0" encoding="utf-8"?>
 <p:sld xmlns:a="http://schemas.openxmlformats.org/drawingml/2006/main" xmlns:p="http://schemas.openxmlformats.org/presentationml/2006/main" xmlns:r="http://schemas.openxmlformats.org/officeDocument/2006/relationships">
   <p:cSld>
     <p:spTree>
@@ -22842,7 +22417,7 @@
 </p:sld>
 </file>
 
-<file path=ppt/slides/slide49.xml><?xml version="1.0" encoding="utf-8"?>
+<file path=ppt/slides/slide43.xml><?xml version="1.0" encoding="utf-8"?>
 <p:sld xmlns:a="http://schemas.openxmlformats.org/drawingml/2006/main" xmlns:p="http://schemas.openxmlformats.org/presentationml/2006/main" xmlns:r="http://schemas.openxmlformats.org/officeDocument/2006/relationships">
   <p:cSld>
     <p:spTree>
@@ -23818,362 +23393,7 @@
 </p:sld>
 </file>
 
-<file path=ppt/slides/slide5.xml><?xml version="1.0" encoding="utf-8"?>
-<p:sld xmlns:a="http://schemas.openxmlformats.org/drawingml/2006/main" xmlns:p="http://schemas.openxmlformats.org/presentationml/2006/main" xmlns:r="http://schemas.openxmlformats.org/officeDocument/2006/relationships">
-  <p:cSld>
-    <p:spTree>
-      <p:nvGrpSpPr>
-        <p:cNvPr id="1" name=""/>
-        <p:cNvGrpSpPr/>
-        <p:nvPr/>
-      </p:nvGrpSpPr>
-      <p:grpSpPr/>
-      <p:sp>
-        <p:nvSpPr>
-          <p:cNvPr id="2" name="Title 1"/>
-          <p:cNvSpPr>
-            <a:spLocks noGrp="1"/>
-          </p:cNvSpPr>
-          <p:nvPr>
-            <p:ph type="title"/>
-          </p:nvPr>
-        </p:nvSpPr>
-        <p:spPr>
-          <a:xfrm>
-            <a:off x="468172" y="650138"/>
-            <a:ext cx="8206740" cy="616305"/>
-          </a:xfrm>
-        </p:spPr>
-        <p:txBody>
-          <a:bodyPr wrap="square" lIns="0" rIns="0" tIns="0" bIns="0">
-            <a:noAutofit/>
-          </a:bodyPr>
-          <a:lstStyle/>
-          <a:p>
-            <a:pPr algn="l">
-              <a:lnSpc>
-                <a:spcPct val="110000"/>
-              </a:lnSpc>
-              <a:buNone/>
-              <a:defRPr sz="2800" b="0">
-                <a:solidFill>
-                  <a:srgbClr val="303437"/>
-                </a:solidFill>
-                <a:latin typeface="Noto Sans"/>
-              </a:defRPr>
-            </a:pPr>
-            <a:r>
-              <a:rPr sz="2800" b="1" lang="ja-JP" altLang="en-US">
-                <a:solidFill>
-                  <a:srgbClr val="303437"/>
-                </a:solidFill>
-                <a:latin typeface="Noto Sans"/>
-                <a:ea typeface="Noto Sans CJK JP"/>
-                <a:cs typeface="Noto Sans"/>
-              </a:rPr>
-              <a:t>英語から中国語、中国語から英語へ</a:t>
-            </a:r>
-          </a:p>
-        </p:txBody>
-      </p:sp>
-      <p:sp>
-        <p:nvSpPr>
-          <p:cNvPr id="3" name="Text Placeholder 2"/>
-          <p:cNvSpPr>
-            <a:spLocks noGrp="1"/>
-          </p:cNvSpPr>
-          <p:nvPr>
-            <p:ph type="body" idx="1"/>
-          </p:nvPr>
-        </p:nvSpPr>
-        <p:spPr>
-          <a:xfrm>
-            <a:off x="594360" y="1463040"/>
-            <a:ext cx="7955279" cy="3044952"/>
-          </a:xfrm>
-        </p:spPr>
-        <p:txBody>
-          <a:bodyPr wrap="square" tIns="91440" bIns="91440">
-            <a:noAutofit/>
-          </a:bodyPr>
-          <a:lstStyle/>
-          <a:p>
-            <a:pPr marL="457200" indent="-355600">
-              <a:lnSpc>
-                <a:spcPts val="2320"/>
-              </a:lnSpc>
-              <a:spcAft>
-                <a:spcPts val="700"/>
-              </a:spcAft>
-              <a:buSzPct val="68205"/>
-              <a:buFont typeface="Noto Sans CJK JP"/>
-              <a:buChar char="●"/>
-              <a:defRPr sz="1950" b="0">
-                <a:solidFill>
-                  <a:srgbClr val="303437"/>
-                </a:solidFill>
-                <a:latin typeface="Noto Sans"/>
-              </a:defRPr>
-            </a:pPr>
-            <a:r>
-              <a:rPr sz="1950" b="0" lang="ja-JP" altLang="en-US">
-                <a:solidFill>
-                  <a:srgbClr val="303437"/>
-                </a:solidFill>
-                <a:latin typeface="Noto Sans"/>
-                <a:ea typeface="Noto Sans CJK JP"/>
-                <a:cs typeface="Noto Sans"/>
-              </a:rPr>
-              <a:t>WMT2020のニュース翻訳では、入力の内容を別の言語で表す。この資料は、公開テストnewstest2020の英語→中国語と中国語→英語を扱う。</a:t>
-            </a:r>
-          </a:p>
-          <a:p>
-            <a:pPr marL="457200" indent="-355600">
-              <a:lnSpc>
-                <a:spcPts val="2320"/>
-              </a:lnSpc>
-              <a:spcAft>
-                <a:spcPts val="700"/>
-              </a:spcAft>
-              <a:buSzPct val="68205"/>
-              <a:buFont typeface="Noto Sans CJK JP"/>
-              <a:buChar char="●"/>
-              <a:defRPr sz="1950" b="0">
-                <a:solidFill>
-                  <a:srgbClr val="303437"/>
-                </a:solidFill>
-                <a:latin typeface="Noto Sans"/>
-              </a:defRPr>
-            </a:pPr>
-            <a:r>
-              <a:rPr sz="1950" b="0" lang="ja-JP" altLang="en-US">
-                <a:solidFill>
-                  <a:srgbClr val="303437"/>
-                </a:solidFill>
-                <a:latin typeface="Noto Sans"/>
-                <a:ea typeface="Noto Sans CJK JP"/>
-                <a:cs typeface="Noto Sans"/>
-              </a:rPr>
-              <a:t>入力に対応する参照訳が公開されている。参照訳は比較のために人が作った訳文で、同じ内容を表すほかの訳もあり得る。</a:t>
-            </a:r>
-          </a:p>
-          <a:p>
-            <a:pPr marL="457200" indent="-355600">
-              <a:lnSpc>
-                <a:spcPts val="2320"/>
-              </a:lnSpc>
-              <a:spcAft>
-                <a:spcPts val="0"/>
-              </a:spcAft>
-              <a:buSzPct val="68205"/>
-              <a:buFont typeface="Noto Sans CJK JP"/>
-              <a:buChar char="●"/>
-              <a:defRPr sz="1950" b="0">
-                <a:solidFill>
-                  <a:srgbClr val="303437"/>
-                </a:solidFill>
-                <a:latin typeface="Noto Sans"/>
-              </a:defRPr>
-            </a:pPr>
-            <a:r>
-              <a:rPr sz="1950" b="0" lang="ja-JP" altLang="en-US">
-                <a:solidFill>
-                  <a:srgbClr val="303437"/>
-                </a:solidFill>
-                <a:latin typeface="Noto Sans"/>
-                <a:ea typeface="Noto Sans CJK JP"/>
-                <a:cs typeface="Noto Sans"/>
-              </a:rPr>
-              <a:t>英語→中国語は英語のニュース、中国語→英語は中国語のニュースを原文にしている。</a:t>
-            </a:r>
-          </a:p>
-        </p:txBody>
-      </p:sp>
-      <p:sp>
-        <p:nvSpPr>
-          <p:cNvPr id="4" name="Title 3"/>
-          <p:cNvSpPr>
-            <a:spLocks noGrp="1"/>
-          </p:cNvSpPr>
-          <p:nvPr>
-            <p:ph type="title" idx="2"/>
-          </p:nvPr>
-        </p:nvSpPr>
-        <p:spPr>
-          <a:xfrm>
-            <a:off x="75895" y="0"/>
-            <a:ext cx="8115300" cy="480060"/>
-          </a:xfrm>
-        </p:spPr>
-        <p:txBody>
-          <a:bodyPr wrap="square" lIns="0" rIns="0" tIns="0" bIns="0" anchor="ctr">
-            <a:noAutofit/>
-          </a:bodyPr>
-          <a:lstStyle/>
-          <a:p>
-            <a:pPr algn="l">
-              <a:lnSpc>
-                <a:spcPct val="110000"/>
-              </a:lnSpc>
-              <a:buNone/>
-              <a:defRPr sz="1400" b="0">
-                <a:solidFill>
-                  <a:srgbClr val="303437"/>
-                </a:solidFill>
-                <a:latin typeface="Noto Sans"/>
-              </a:defRPr>
-            </a:pPr>
-            <a:r>
-              <a:rPr sz="1400" b="1" lang="ja-JP" altLang="en-US">
-                <a:solidFill>
-                  <a:srgbClr val="FFFEF8"/>
-                </a:solidFill>
-                <a:latin typeface="Noto Sans"/>
-                <a:ea typeface="Noto Sans CJK JP"/>
-                <a:cs typeface="Noto Sans"/>
-              </a:rPr>
-              <a:t>1. ニュースを、別の言語へ訳す</a:t>
-            </a:r>
-          </a:p>
-        </p:txBody>
-      </p:sp>
-      <p:sp>
-        <p:nvSpPr>
-          <p:cNvPr id="5" name="sources"/>
-          <p:cNvSpPr txBox="1"/>
-          <p:nvPr/>
-        </p:nvSpPr>
-        <p:spPr>
-          <a:xfrm>
-            <a:off x="502920" y="4700016"/>
-            <a:ext cx="8183879" cy="530352"/>
-          </a:xfrm>
-          <a:prstGeom prst="rect">
-            <a:avLst/>
-          </a:prstGeom>
-          <a:noFill/>
-        </p:spPr>
-        <p:txBody>
-          <a:bodyPr wrap="square" lIns="0" rIns="0" tIns="0" bIns="0">
-            <a:noAutofit/>
-          </a:bodyPr>
-          <a:lstStyle/>
-          <a:p>
-            <a:pPr algn="l">
-              <a:lnSpc>
-                <a:spcPts val="940"/>
-              </a:lnSpc>
-              <a:spcBef>
-                <a:spcPts val="0"/>
-              </a:spcBef>
-              <a:spcAft>
-                <a:spcPts val="300"/>
-              </a:spcAft>
-              <a:buNone/>
-              <a:defRPr sz="810" b="0">
-                <a:solidFill>
-                  <a:srgbClr val="303437"/>
-                </a:solidFill>
-                <a:latin typeface="Noto Sans"/>
-              </a:defRPr>
-            </a:pPr>
-            <a:r>
-              <a:rPr sz="810" b="0" lang="ja-JP" altLang="en-US">
-                <a:solidFill>
-                  <a:srgbClr val="626669"/>
-                </a:solidFill>
-                <a:latin typeface="Noto Sans"/>
-                <a:ea typeface="Noto Sans CJK JP"/>
-                <a:cs typeface="Noto Sans"/>
-              </a:rPr>
-              <a:t>[1] Barrault et al. (2020). Findings of the 2020 Conference on Machine Translation (WMT20). WMT, pp.1–55.</a:t>
-            </a:r>
-            <a:r>
-              <a:rPr sz="810" b="0" lang="ja-JP" altLang="en-US">
-                <a:solidFill>
-                  <a:srgbClr val="626669"/>
-                </a:solidFill>
-                <a:latin typeface="Noto Sans"/>
-                <a:ea typeface="Noto Sans CJK JP"/>
-                <a:cs typeface="Noto Sans"/>
-              </a:rPr>
-              <a:t>  </a:t>
-            </a:r>
-            <a:r>
-              <a:rPr sz="810" b="0" lang="ja-JP" altLang="en-US">
-                <a:solidFill>
-                  <a:srgbClr val="626669"/>
-                </a:solidFill>
-                <a:latin typeface="Noto Sans"/>
-                <a:ea typeface="Noto Sans CJK JP"/>
-                <a:cs typeface="Noto Sans"/>
-                <a:hlinkClick r:id="rId2"/>
-              </a:rPr>
-              <a:t>https://aclanthology.org/2020.wmt-1.1/</a:t>
-            </a:r>
-          </a:p>
-          <a:p>
-            <a:pPr>
-              <a:lnSpc>
-                <a:spcPts val="940"/>
-              </a:lnSpc>
-              <a:spcAft>
-                <a:spcPts val="300"/>
-              </a:spcAft>
-              <a:buNone/>
-              <a:defRPr sz="810" b="0">
-                <a:solidFill>
-                  <a:srgbClr val="303437"/>
-                </a:solidFill>
-                <a:latin typeface="Noto Sans"/>
-              </a:defRPr>
-            </a:pPr>
-            <a:r>
-              <a:rPr sz="810" b="0" lang="ja-JP" altLang="en-US">
-                <a:solidFill>
-                  <a:srgbClr val="626669"/>
-                </a:solidFill>
-                <a:latin typeface="Noto Sans"/>
-                <a:ea typeface="Noto Sans CJK JP"/>
-                <a:cs typeface="Noto Sans"/>
-              </a:rPr>
-              <a:t>[2] WMT20. Official test.tgz: newstest2020 / newstestB2020, English–Chinese.</a:t>
-            </a:r>
-            <a:r>
-              <a:rPr sz="810" b="0" lang="ja-JP" altLang="en-US">
-                <a:solidFill>
-                  <a:srgbClr val="626669"/>
-                </a:solidFill>
-                <a:latin typeface="Noto Sans"/>
-                <a:ea typeface="Noto Sans CJK JP"/>
-                <a:cs typeface="Noto Sans"/>
-              </a:rPr>
-              <a:t>  </a:t>
-            </a:r>
-            <a:r>
-              <a:rPr sz="810" b="0" lang="ja-JP" altLang="en-US">
-                <a:solidFill>
-                  <a:srgbClr val="626669"/>
-                </a:solidFill>
-                <a:latin typeface="Noto Sans"/>
-                <a:ea typeface="Noto Sans CJK JP"/>
-                <a:cs typeface="Noto Sans"/>
-                <a:hlinkClick r:id="rId3"/>
-              </a:rPr>
-              <a:t>https://data.statmt.org/wmt20/translation-task/test.tgz</a:t>
-            </a:r>
-          </a:p>
-        </p:txBody>
-      </p:sp>
-    </p:spTree>
-  </p:cSld>
-  <p:clrMapOvr>
-    <a:masterClrMapping/>
-  </p:clrMapOvr>
-</p:sld>
-</file>
-
-<file path=ppt/slides/slide51.xml><?xml version="1.0" encoding="utf-8"?>
+<file path=ppt/slides/slide44.xml><?xml version="1.0" encoding="utf-8"?>
 <p:sld xmlns:a="http://schemas.openxmlformats.org/drawingml/2006/main" xmlns:p="http://schemas.openxmlformats.org/presentationml/2006/main" xmlns:r="http://schemas.openxmlformats.org/officeDocument/2006/relationships">
   <p:cSld>
     <p:spTree>
@@ -24698,7 +23918,7 @@
 </p:sld>
 </file>
 
-<file path=ppt/slides/slide52.xml><?xml version="1.0" encoding="utf-8"?>
+<file path=ppt/slides/slide45.xml><?xml version="1.0" encoding="utf-8"?>
 <p:sld xmlns:a="http://schemas.openxmlformats.org/drawingml/2006/main" xmlns:p="http://schemas.openxmlformats.org/presentationml/2006/main" xmlns:r="http://schemas.openxmlformats.org/officeDocument/2006/relationships">
   <p:cSld>
     <p:spTree>
@@ -25324,7 +24544,7 @@
 </p:sld>
 </file>
 
-<file path=ppt/slides/slide54.xml><?xml version="1.0" encoding="utf-8"?>
+<file path=ppt/slides/slide46.xml><?xml version="1.0" encoding="utf-8"?>
 <p:sld xmlns:a="http://schemas.openxmlformats.org/drawingml/2006/main" xmlns:p="http://schemas.openxmlformats.org/presentationml/2006/main" xmlns:r="http://schemas.openxmlformats.org/officeDocument/2006/relationships">
   <p:cSld>
     <p:spTree>
@@ -25598,7 +24818,7 @@
 </p:sld>
 </file>
 
-<file path=ppt/slides/slide55.xml><?xml version="1.0" encoding="utf-8"?>
+<file path=ppt/slides/slide47.xml><?xml version="1.0" encoding="utf-8"?>
 <p:sld xmlns:a="http://schemas.openxmlformats.org/drawingml/2006/main" xmlns:p="http://schemas.openxmlformats.org/presentationml/2006/main" xmlns:r="http://schemas.openxmlformats.org/officeDocument/2006/relationships">
   <p:cSld>
     <p:spTree>
@@ -25712,7 +24932,7 @@
 </p:sld>
 </file>
 
-<file path=ppt/slides/slide57.xml><?xml version="1.0" encoding="utf-8"?>
+<file path=ppt/slides/slide48.xml><?xml version="1.0" encoding="utf-8"?>
 <p:sld xmlns:a="http://schemas.openxmlformats.org/drawingml/2006/main" xmlns:p="http://schemas.openxmlformats.org/presentationml/2006/main" xmlns:r="http://schemas.openxmlformats.org/officeDocument/2006/relationships">
   <p:cSld>
     <p:spTree>
@@ -26260,7 +25480,7 @@
 </p:sld>
 </file>
 
-<file path=ppt/slides/slide58.xml><?xml version="1.0" encoding="utf-8"?>
+<file path=ppt/slides/slide49.xml><?xml version="1.0" encoding="utf-8"?>
 <p:sld xmlns:a="http://schemas.openxmlformats.org/drawingml/2006/main" xmlns:p="http://schemas.openxmlformats.org/presentationml/2006/main" xmlns:r="http://schemas.openxmlformats.org/officeDocument/2006/relationships">
   <p:cSld>
     <p:spTree>
@@ -26808,7 +26028,7 @@
 </p:sld>
 </file>
 
-<file path=ppt/slides/slide59.xml><?xml version="1.0" encoding="utf-8"?>
+<file path=ppt/slides/slide5.xml><?xml version="1.0" encoding="utf-8"?>
 <p:sld xmlns:a="http://schemas.openxmlformats.org/drawingml/2006/main" xmlns:p="http://schemas.openxmlformats.org/presentationml/2006/main" xmlns:r="http://schemas.openxmlformats.org/officeDocument/2006/relationships">
   <p:cSld>
     <p:spTree>
@@ -26861,14 +26081,127 @@
                 <a:ea typeface="Noto Sans CJK JP"/>
                 <a:cs typeface="Noto Sans"/>
               </a:rPr>
-              <a:t>参考文献</a:t>
+              <a:t>英語から中国語、中国語から英語へ</a:t>
             </a:r>
           </a:p>
         </p:txBody>
       </p:sp>
       <p:sp>
         <p:nvSpPr>
-          <p:cNvPr id="3" name="Title 2"/>
+          <p:cNvPr id="3" name="Text Placeholder 2"/>
+          <p:cNvSpPr>
+            <a:spLocks noGrp="1"/>
+          </p:cNvSpPr>
+          <p:nvPr>
+            <p:ph type="body" idx="1"/>
+          </p:nvPr>
+        </p:nvSpPr>
+        <p:spPr>
+          <a:xfrm>
+            <a:off x="594360" y="1463040"/>
+            <a:ext cx="7955279" cy="3044952"/>
+          </a:xfrm>
+        </p:spPr>
+        <p:txBody>
+          <a:bodyPr wrap="square" tIns="91440" bIns="91440">
+            <a:noAutofit/>
+          </a:bodyPr>
+          <a:lstStyle/>
+          <a:p>
+            <a:pPr marL="457200" indent="-355600">
+              <a:lnSpc>
+                <a:spcPts val="2320"/>
+              </a:lnSpc>
+              <a:spcAft>
+                <a:spcPts val="700"/>
+              </a:spcAft>
+              <a:buSzPct val="68205"/>
+              <a:buFont typeface="Noto Sans CJK JP"/>
+              <a:buChar char="●"/>
+              <a:defRPr sz="1950" b="0">
+                <a:solidFill>
+                  <a:srgbClr val="303437"/>
+                </a:solidFill>
+                <a:latin typeface="Noto Sans"/>
+              </a:defRPr>
+            </a:pPr>
+            <a:r>
+              <a:rPr sz="1950" b="0" lang="ja-JP" altLang="en-US">
+                <a:solidFill>
+                  <a:srgbClr val="303437"/>
+                </a:solidFill>
+                <a:latin typeface="Noto Sans"/>
+                <a:ea typeface="Noto Sans CJK JP"/>
+                <a:cs typeface="Noto Sans"/>
+              </a:rPr>
+              <a:t>WMT2020のニュース翻訳では、入力の内容を別の言語で表す。この資料は、公開テストnewstest2020の英語→中国語と中国語→英語を扱う。</a:t>
+            </a:r>
+          </a:p>
+          <a:p>
+            <a:pPr marL="457200" indent="-355600">
+              <a:lnSpc>
+                <a:spcPts val="2320"/>
+              </a:lnSpc>
+              <a:spcAft>
+                <a:spcPts val="700"/>
+              </a:spcAft>
+              <a:buSzPct val="68205"/>
+              <a:buFont typeface="Noto Sans CJK JP"/>
+              <a:buChar char="●"/>
+              <a:defRPr sz="1950" b="0">
+                <a:solidFill>
+                  <a:srgbClr val="303437"/>
+                </a:solidFill>
+                <a:latin typeface="Noto Sans"/>
+              </a:defRPr>
+            </a:pPr>
+            <a:r>
+              <a:rPr sz="1950" b="0" lang="ja-JP" altLang="en-US">
+                <a:solidFill>
+                  <a:srgbClr val="303437"/>
+                </a:solidFill>
+                <a:latin typeface="Noto Sans"/>
+                <a:ea typeface="Noto Sans CJK JP"/>
+                <a:cs typeface="Noto Sans"/>
+              </a:rPr>
+              <a:t>入力に対応する参照訳が公開されている。参照訳は比較のために人が作った訳文で、同じ内容を表すほかの訳もあり得る。</a:t>
+            </a:r>
+          </a:p>
+          <a:p>
+            <a:pPr marL="457200" indent="-355600">
+              <a:lnSpc>
+                <a:spcPts val="2320"/>
+              </a:lnSpc>
+              <a:spcAft>
+                <a:spcPts val="0"/>
+              </a:spcAft>
+              <a:buSzPct val="68205"/>
+              <a:buFont typeface="Noto Sans CJK JP"/>
+              <a:buChar char="●"/>
+              <a:defRPr sz="1950" b="0">
+                <a:solidFill>
+                  <a:srgbClr val="303437"/>
+                </a:solidFill>
+                <a:latin typeface="Noto Sans"/>
+              </a:defRPr>
+            </a:pPr>
+            <a:r>
+              <a:rPr sz="1950" b="0" lang="ja-JP" altLang="en-US">
+                <a:solidFill>
+                  <a:srgbClr val="303437"/>
+                </a:solidFill>
+                <a:latin typeface="Noto Sans"/>
+                <a:ea typeface="Noto Sans CJK JP"/>
+                <a:cs typeface="Noto Sans"/>
+              </a:rPr>
+              <a:t>英語→中国語は英語のニュース、中国語→英語は中国語のニュースを原文にしている。</a:t>
+            </a:r>
+          </a:p>
+        </p:txBody>
+      </p:sp>
+      <p:sp>
+        <p:nvSpPr>
+          <p:cNvPr id="4" name="Title 3"/>
           <p:cNvSpPr>
             <a:spLocks noGrp="1"/>
           </p:cNvSpPr>
@@ -26909,21 +26242,21 @@
                 <a:ea typeface="Noto Sans CJK JP"/>
                 <a:cs typeface="Noto Sans"/>
               </a:rPr>
-              <a:t>Appendix: 3. 参考文献</a:t>
+              <a:t>1. ニュースを、別の言語へ訳す</a:t>
             </a:r>
           </a:p>
         </p:txBody>
       </p:sp>
       <p:sp>
         <p:nvSpPr>
-          <p:cNvPr id="4" name="TextBox 3"/>
+          <p:cNvPr id="5" name="sources"/>
           <p:cNvSpPr txBox="1"/>
           <p:nvPr/>
         </p:nvSpPr>
         <p:spPr>
           <a:xfrm>
-            <a:off x="548640" y="1325880"/>
-            <a:ext cx="8046720" cy="594360"/>
+            <a:off x="502920" y="4700016"/>
+            <a:ext cx="8183879" cy="530352"/>
           </a:xfrm>
           <a:prstGeom prst="rect">
             <a:avLst/>
@@ -26938,78 +26271,24 @@
           <a:p>
             <a:pPr algn="l">
               <a:lnSpc>
-                <a:spcPts val="1920"/>
-              </a:lnSpc>
-              <a:spcBef>
-                <a:spcPts val="0"/>
-              </a:spcBef>
-              <a:spcAft>
-                <a:spcPts val="0"/>
-              </a:spcAft>
-              <a:buNone/>
-              <a:defRPr sz="1700" b="0">
-                <a:solidFill>
-                  <a:srgbClr val="303437"/>
-                </a:solidFill>
-                <a:latin typeface="Noto Sans"/>
-              </a:defRPr>
-            </a:pPr>
-            <a:r>
-              <a:rPr sz="1700" b="1" lang="ja-JP" altLang="en-US">
-                <a:solidFill>
-                  <a:srgbClr val="303437"/>
-                </a:solidFill>
-                <a:latin typeface="Noto Sans"/>
-                <a:ea typeface="Noto Sans CJK JP"/>
-                <a:cs typeface="Noto Sans"/>
-              </a:rPr>
-              <a:t>CLEVA: Chinese Language Models EVAluation Platform</a:t>
-            </a:r>
-          </a:p>
-        </p:txBody>
-      </p:sp>
-      <p:sp>
-        <p:nvSpPr>
-          <p:cNvPr id="5" name="TextBox 4"/>
-          <p:cNvSpPr txBox="1"/>
-          <p:nvPr/>
-        </p:nvSpPr>
-        <p:spPr>
-          <a:xfrm>
-            <a:off x="548640" y="1956815"/>
-            <a:ext cx="8046720" cy="228600"/>
-          </a:xfrm>
-          <a:prstGeom prst="rect">
-            <a:avLst/>
-          </a:prstGeom>
-          <a:noFill/>
-        </p:spPr>
-        <p:txBody>
-          <a:bodyPr wrap="square" lIns="0" rIns="0" tIns="0" bIns="0">
-            <a:noAutofit/>
-          </a:bodyPr>
-          <a:lstStyle/>
-          <a:p>
-            <a:pPr algn="l">
-              <a:lnSpc>
-                <a:spcPts val="1404"/>
-              </a:lnSpc>
-              <a:spcBef>
-                <a:spcPts val="0"/>
-              </a:spcBef>
-              <a:spcAft>
-                <a:spcPts val="0"/>
-              </a:spcAft>
-              <a:buNone/>
-              <a:defRPr sz="1200" b="0">
-                <a:solidFill>
-                  <a:srgbClr val="303437"/>
-                </a:solidFill>
-                <a:latin typeface="Noto Sans"/>
-              </a:defRPr>
-            </a:pPr>
-            <a:r>
-              <a:rPr sz="1200" b="0" lang="ja-JP" altLang="en-US">
+                <a:spcPts val="940"/>
+              </a:lnSpc>
+              <a:spcBef>
+                <a:spcPts val="0"/>
+              </a:spcBef>
+              <a:spcAft>
+                <a:spcPts val="300"/>
+              </a:spcAft>
+              <a:buNone/>
+              <a:defRPr sz="810" b="0">
+                <a:solidFill>
+                  <a:srgbClr val="303437"/>
+                </a:solidFill>
+                <a:latin typeface="Noto Sans"/>
+              </a:defRPr>
+            </a:pPr>
+            <a:r>
+              <a:rPr sz="810" b="0" lang="ja-JP" altLang="en-US">
                 <a:solidFill>
                   <a:srgbClr val="626669"/>
                 </a:solidFill>
@@ -27017,216 +26296,50 @@
                 <a:ea typeface="Noto Sans CJK JP"/>
                 <a:cs typeface="Noto Sans"/>
               </a:rPr>
-              <a:t>Li et al. · 2023 · EMNLP System Demonstrations</a:t>
-            </a:r>
-          </a:p>
-        </p:txBody>
-      </p:sp>
-      <p:sp>
-        <p:nvSpPr>
-          <p:cNvPr id="6" name="TextBox 5"/>
-          <p:cNvSpPr txBox="1"/>
-          <p:nvPr/>
-        </p:nvSpPr>
-        <p:spPr>
-          <a:xfrm>
-            <a:off x="548640" y="2240280"/>
-            <a:ext cx="8046720" cy="457200"/>
-          </a:xfrm>
-          <a:prstGeom prst="rect">
-            <a:avLst/>
-          </a:prstGeom>
-          <a:noFill/>
-        </p:spPr>
-        <p:txBody>
-          <a:bodyPr wrap="square" lIns="0" rIns="0" tIns="0" bIns="0">
-            <a:noAutofit/>
-          </a:bodyPr>
-          <a:lstStyle/>
-          <a:p>
-            <a:pPr algn="l">
-              <a:lnSpc>
-                <a:spcPts val="1823"/>
-              </a:lnSpc>
-              <a:spcBef>
-                <a:spcPts val="0"/>
-              </a:spcBef>
-              <a:spcAft>
-                <a:spcPts val="0"/>
-              </a:spcAft>
-              <a:buNone/>
-              <a:defRPr sz="1600" b="0">
-                <a:solidFill>
-                  <a:srgbClr val="303437"/>
-                </a:solidFill>
-                <a:latin typeface="Noto Sans"/>
-              </a:defRPr>
-            </a:pPr>
-            <a:r>
-              <a:rPr sz="1600" b="0" lang="ja-JP" altLang="en-US">
-                <a:solidFill>
-                  <a:srgbClr val="303437"/>
-                </a:solidFill>
-                <a:latin typeface="Noto Sans"/>
-                <a:ea typeface="Noto Sans CJK JP"/>
-                <a:cs typeface="Noto Sans"/>
-              </a:rPr>
-              <a:t>過去のWMTから英中翻訳を採用。公開見出し例とSacreBLEUの使用を記す。</a:t>
-            </a:r>
-          </a:p>
-        </p:txBody>
-      </p:sp>
-      <p:sp>
-        <p:nvSpPr>
-          <p:cNvPr id="7" name="TextBox 6"/>
-          <p:cNvSpPr txBox="1"/>
-          <p:nvPr/>
-        </p:nvSpPr>
-        <p:spPr>
-          <a:xfrm>
-            <a:off x="548640" y="2752344"/>
-            <a:ext cx="8046720" cy="228600"/>
-          </a:xfrm>
-          <a:prstGeom prst="rect">
-            <a:avLst/>
-          </a:prstGeom>
-          <a:noFill/>
-        </p:spPr>
-        <p:txBody>
-          <a:bodyPr wrap="square" lIns="0" rIns="0" tIns="0" bIns="0">
-            <a:noAutofit/>
-          </a:bodyPr>
-          <a:lstStyle/>
-          <a:p>
-            <a:pPr algn="l">
-              <a:lnSpc>
-                <a:spcPts val="1263"/>
-              </a:lnSpc>
-              <a:spcBef>
-                <a:spcPts val="0"/>
-              </a:spcBef>
-              <a:spcAft>
-                <a:spcPts val="0"/>
-              </a:spcAft>
-              <a:buNone/>
-              <a:defRPr sz="1080" b="0">
-                <a:solidFill>
-                  <a:srgbClr val="303437"/>
-                </a:solidFill>
-                <a:latin typeface="Noto Sans"/>
-              </a:defRPr>
-            </a:pPr>
-            <a:r>
-              <a:rPr sz="1080" b="0" lang="ja-JP" altLang="en-US">
-                <a:solidFill>
-                  <a:srgbClr val="2166AC"/>
+              <a:t>[1] Barrault et al. (2020). Findings of the 2020 Conference on Machine Translation (WMT20). WMT, pp.1–55.</a:t>
+            </a:r>
+            <a:r>
+              <a:rPr sz="810" b="0" lang="ja-JP" altLang="en-US">
+                <a:solidFill>
+                  <a:srgbClr val="626669"/>
+                </a:solidFill>
+                <a:latin typeface="Noto Sans"/>
+                <a:ea typeface="Noto Sans CJK JP"/>
+                <a:cs typeface="Noto Sans"/>
+              </a:rPr>
+              <a:t>  </a:t>
+            </a:r>
+            <a:r>
+              <a:rPr sz="810" b="0" lang="ja-JP" altLang="en-US">
+                <a:solidFill>
+                  <a:srgbClr val="626669"/>
                 </a:solidFill>
                 <a:latin typeface="Noto Sans"/>
                 <a:ea typeface="Noto Sans CJK JP"/>
                 <a:cs typeface="Noto Sans"/>
                 <a:hlinkClick r:id="rId2"/>
               </a:rPr>
-              <a:t>https://aclanthology.org/2023.emnlp-demo.17/</a:t>
-            </a:r>
-          </a:p>
-        </p:txBody>
-      </p:sp>
-      <p:sp>
-        <p:nvSpPr>
-          <p:cNvPr id="8" name="TextBox 7"/>
-          <p:cNvSpPr txBox="1"/>
-          <p:nvPr/>
-        </p:nvSpPr>
-        <p:spPr>
-          <a:xfrm>
-            <a:off x="548640" y="3063239"/>
-            <a:ext cx="8046720" cy="594360"/>
-          </a:xfrm>
-          <a:prstGeom prst="rect">
-            <a:avLst/>
-          </a:prstGeom>
-          <a:noFill/>
-        </p:spPr>
-        <p:txBody>
-          <a:bodyPr wrap="square" lIns="0" rIns="0" tIns="0" bIns="0">
-            <a:noAutofit/>
-          </a:bodyPr>
-          <a:lstStyle/>
-          <a:p>
-            <a:pPr algn="l">
-              <a:lnSpc>
-                <a:spcPts val="1920"/>
-              </a:lnSpc>
-              <a:spcBef>
-                <a:spcPts val="0"/>
-              </a:spcBef>
-              <a:spcAft>
-                <a:spcPts val="0"/>
-              </a:spcAft>
-              <a:buNone/>
-              <a:defRPr sz="1700" b="0">
-                <a:solidFill>
-                  <a:srgbClr val="303437"/>
-                </a:solidFill>
-                <a:latin typeface="Noto Sans"/>
-              </a:defRPr>
-            </a:pPr>
-            <a:r>
-              <a:rPr sz="1700" b="1" lang="ja-JP" altLang="en-US">
-                <a:solidFill>
-                  <a:srgbClr val="303437"/>
-                </a:solidFill>
-                <a:latin typeface="Noto Sans"/>
-                <a:ea typeface="Noto Sans CJK JP"/>
-                <a:cs typeface="Noto Sans"/>
-              </a:rPr>
-              <a:t>CLEVATranslationScenario and Converter</a:t>
-            </a:r>
-          </a:p>
-        </p:txBody>
-      </p:sp>
-      <p:sp>
-        <p:nvSpPr>
-          <p:cNvPr id="9" name="TextBox 8"/>
-          <p:cNvSpPr txBox="1"/>
-          <p:nvPr/>
-        </p:nvSpPr>
-        <p:spPr>
-          <a:xfrm>
-            <a:off x="548640" y="3694175"/>
-            <a:ext cx="8046720" cy="228600"/>
-          </a:xfrm>
-          <a:prstGeom prst="rect">
-            <a:avLst/>
-          </a:prstGeom>
-          <a:noFill/>
-        </p:spPr>
-        <p:txBody>
-          <a:bodyPr wrap="square" lIns="0" rIns="0" tIns="0" bIns="0">
-            <a:noAutofit/>
-          </a:bodyPr>
-          <a:lstStyle/>
-          <a:p>
-            <a:pPr algn="l">
-              <a:lnSpc>
-                <a:spcPts val="1404"/>
-              </a:lnSpc>
-              <a:spcBef>
-                <a:spcPts val="0"/>
-              </a:spcBef>
-              <a:spcAft>
-                <a:spcPts val="0"/>
-              </a:spcAft>
-              <a:buNone/>
-              <a:defRPr sz="1200" b="0">
-                <a:solidFill>
-                  <a:srgbClr val="303437"/>
-                </a:solidFill>
-                <a:latin typeface="Noto Sans"/>
-              </a:defRPr>
-            </a:pPr>
-            <a:r>
-              <a:rPr sz="1200" b="0" lang="ja-JP" altLang="en-US">
+              <a:t>https://aclanthology.org/2020.wmt-1.1/</a:t>
+            </a:r>
+          </a:p>
+          <a:p>
+            <a:pPr>
+              <a:lnSpc>
+                <a:spcPts val="940"/>
+              </a:lnSpc>
+              <a:spcAft>
+                <a:spcPts val="300"/>
+              </a:spcAft>
+              <a:buNone/>
+              <a:defRPr sz="810" b="0">
+                <a:solidFill>
+                  <a:srgbClr val="303437"/>
+                </a:solidFill>
+                <a:latin typeface="Noto Sans"/>
+              </a:defRPr>
+            </a:pPr>
+            <a:r>
+              <a:rPr sz="810" b="0" lang="ja-JP" altLang="en-US">
                 <a:solidFill>
                   <a:srgbClr val="626669"/>
                 </a:solidFill>
@@ -27234,116 +26347,30 @@
                 <a:ea typeface="Noto Sans CJK JP"/>
                 <a:cs typeface="Noto Sans"/>
               </a:rPr>
-              <a:t>Stanford CRFM · 2023 · HELM v0.4.0 implementation</a:t>
-            </a:r>
-          </a:p>
-        </p:txBody>
-      </p:sp>
-      <p:sp>
-        <p:nvSpPr>
-          <p:cNvPr id="10" name="TextBox 9"/>
-          <p:cNvSpPr txBox="1"/>
-          <p:nvPr/>
-        </p:nvSpPr>
-        <p:spPr>
-          <a:xfrm>
-            <a:off x="548640" y="3977639"/>
-            <a:ext cx="8046720" cy="457200"/>
-          </a:xfrm>
-          <a:prstGeom prst="rect">
-            <a:avLst/>
-          </a:prstGeom>
-          <a:noFill/>
-        </p:spPr>
-        <p:txBody>
-          <a:bodyPr wrap="square" lIns="0" rIns="0" tIns="0" bIns="0">
-            <a:noAutofit/>
-          </a:bodyPr>
-          <a:lstStyle/>
-          <a:p>
-            <a:pPr algn="l">
-              <a:lnSpc>
-                <a:spcPts val="1823"/>
-              </a:lnSpc>
-              <a:spcBef>
-                <a:spcPts val="0"/>
-              </a:spcBef>
-              <a:spcAft>
-                <a:spcPts val="0"/>
-              </a:spcAft>
-              <a:buNone/>
-              <a:defRPr sz="1600" b="0">
-                <a:solidFill>
-                  <a:srgbClr val="303437"/>
-                </a:solidFill>
-                <a:latin typeface="Noto Sans"/>
-              </a:defRPr>
-            </a:pPr>
-            <a:r>
-              <a:rPr sz="1600" b="0" lang="ja-JP" altLang="en-US">
-                <a:solidFill>
-                  <a:srgbClr val="303437"/>
-                </a:solidFill>
-                <a:latin typeface="Noto Sans"/>
-                <a:ea typeface="Noto Sans CJK JP"/>
-                <a:cs typeface="Noto Sans"/>
-              </a:rPr>
-              <a:t>変換済みデータとテンプレートから入力と参照を構成し、二方向の翻訳例を示す。</a:t>
-            </a:r>
-          </a:p>
-        </p:txBody>
-      </p:sp>
-      <p:sp>
-        <p:nvSpPr>
-          <p:cNvPr id="11" name="TextBox 10"/>
-          <p:cNvSpPr txBox="1"/>
-          <p:nvPr/>
-        </p:nvSpPr>
-        <p:spPr>
-          <a:xfrm>
-            <a:off x="548640" y="4489704"/>
-            <a:ext cx="8046720" cy="228600"/>
-          </a:xfrm>
-          <a:prstGeom prst="rect">
-            <a:avLst/>
-          </a:prstGeom>
-          <a:noFill/>
-        </p:spPr>
-        <p:txBody>
-          <a:bodyPr wrap="square" lIns="0" rIns="0" tIns="0" bIns="0">
-            <a:noAutofit/>
-          </a:bodyPr>
-          <a:lstStyle/>
-          <a:p>
-            <a:pPr algn="l">
-              <a:lnSpc>
-                <a:spcPts val="1263"/>
-              </a:lnSpc>
-              <a:spcBef>
-                <a:spcPts val="0"/>
-              </a:spcBef>
-              <a:spcAft>
-                <a:spcPts val="0"/>
-              </a:spcAft>
-              <a:buNone/>
-              <a:defRPr sz="1080" b="0">
-                <a:solidFill>
-                  <a:srgbClr val="303437"/>
-                </a:solidFill>
-                <a:latin typeface="Noto Sans"/>
-              </a:defRPr>
-            </a:pPr>
-            <a:r>
-              <a:rPr sz="1080" b="0" lang="ja-JP" altLang="en-US">
-                <a:solidFill>
-                  <a:srgbClr val="2166AC"/>
+              <a:t>[2] WMT20. Official test.tgz: newstest2020 / newstestB2020, English–Chinese.</a:t>
+            </a:r>
+            <a:r>
+              <a:rPr sz="810" b="0" lang="ja-JP" altLang="en-US">
+                <a:solidFill>
+                  <a:srgbClr val="626669"/>
+                </a:solidFill>
+                <a:latin typeface="Noto Sans"/>
+                <a:ea typeface="Noto Sans CJK JP"/>
+                <a:cs typeface="Noto Sans"/>
+              </a:rPr>
+              <a:t>  </a:t>
+            </a:r>
+            <a:r>
+              <a:rPr sz="810" b="0" lang="ja-JP" altLang="en-US">
+                <a:solidFill>
+                  <a:srgbClr val="626669"/>
                 </a:solidFill>
                 <a:latin typeface="Noto Sans"/>
                 <a:ea typeface="Noto Sans CJK JP"/>
                 <a:cs typeface="Noto Sans"/>
                 <a:hlinkClick r:id="rId3"/>
               </a:rPr>
-              <a:t>https://github.com/stanford-crfm/helm/blob/v0.4.0/src/helm/benchmark/scenarios/cleva_scenario.py</a:t>
+              <a:t>https://data.statmt.org/wmt20/translation-task/test.tgz</a:t>
             </a:r>
           </a:p>
         </p:txBody>
@@ -28033,36 +27060,6 @@
               <a:t>Houseは下院、rebukesは非難を表す。下院の動きに対し、butの後にはトランプ氏の反対の動きが続く。plansは、拒否権を行使する意向を表す。</a:t>
             </a:r>
           </a:p>
-          <a:p>
-            <a:pPr marL="457200" indent="-355600">
-              <a:lnSpc>
-                <a:spcPts val="2320"/>
-              </a:lnSpc>
-              <a:spcAft>
-                <a:spcPts val="700"/>
-              </a:spcAft>
-              <a:buSzPct val="68205"/>
-              <a:buFont typeface="Noto Sans CJK JP"/>
-              <a:buChar char="●"/>
-              <a:defRPr sz="1950" b="0">
-                <a:solidFill>
-                  <a:srgbClr val="303437"/>
-                </a:solidFill>
-                <a:latin typeface="Noto Sans"/>
-              </a:defRPr>
-            </a:pPr>
-            <a:r>
-              <a:rPr sz="1950" b="0" lang="ja-JP" altLang="en-US">
-                <a:solidFill>
-                  <a:srgbClr val="303437"/>
-                </a:solidFill>
-                <a:latin typeface="Noto Sans"/>
-                <a:ea typeface="Noto Sans CJK JP"/>
-                <a:cs typeface="Noto Sans"/>
-              </a:rPr>
-              <a:t>この見出しと中国語の参照訳は、CLEVA論文の翻訳例にも掲載されている。</a:t>
-            </a:r>
-          </a:p>
         </p:txBody>
       </p:sp>
       <p:sp>
@@ -28175,46 +27172,6 @@
                 <a:hlinkClick r:id="rId2"/>
               </a:rPr>
               <a:t>https://data.statmt.org/wmt20/translation-task/test.tgz</a:t>
-            </a:r>
-          </a:p>
-          <a:p>
-            <a:pPr>
-              <a:lnSpc>
-                <a:spcPts val="940"/>
-              </a:lnSpc>
-              <a:spcAft>
-                <a:spcPts val="300"/>
-              </a:spcAft>
-              <a:buNone/>
-              <a:defRPr sz="810" b="0">
-                <a:solidFill>
-                  <a:srgbClr val="303437"/>
-                </a:solidFill>
-                <a:latin typeface="Noto Sans"/>
-              </a:defRPr>
-            </a:pPr>
-            <a:r>
-              <a:rPr sz="810" b="0" lang="ja-JP" altLang="en-US">
-                <a:solidFill>
-                  <a:srgbClr val="626669"/>
-                </a:solidFill>
-                <a:latin typeface="Noto Sans"/>
-                <a:ea typeface="Noto Sans CJK JP"/>
-                <a:cs typeface="Noto Sans"/>
-              </a:rPr>
-              <a:t>[2] Li et al. (2023). CLEVA: Chinese Language Models EVAluation Platform. EMNLP System Demonstrations.  </a:t>
-            </a:r>
-            <a:r>
-              <a:rPr sz="810" b="0" lang="ja-JP" altLang="en-US">
-                <a:solidFill>
-                  <a:srgbClr val="626669"/>
-                </a:solidFill>
-                <a:latin typeface="Noto Sans"/>
-                <a:ea typeface="Noto Sans CJK JP"/>
-                <a:cs typeface="Noto Sans"/>
-                <a:hlinkClick r:id="rId3"/>
-              </a:rPr>
-              <a:t>https://aclanthology.org/2023.emnlp-demo.17/</a:t>
             </a:r>
           </a:p>
         </p:txBody>

</xml_diff>